<commit_message>
feat: per-year animated hazard grid in dashboard
- Compute IDW hazard grid per year (2018–2023, 289 cells each)
- Beach-only for 2018–2019, composite for 2020–2023
- Inject hazard_by_year into dashboard_data.json
- buildHazardLayer(year) now rebuilds on every slider change
- initCharts() seeds with year 2018; setYear() drives updates

Co-Authored-By: Claude Sonnet 4.6 <noreply@anthropic.com>
</commit_message>
<xml_diff>
--- a/Marine_Litter_Hazard_Sardinia.pptx
+++ b/Marine_Litter_Hazard_Sardinia.pptx
@@ -4,6 +4,9 @@
   <p:sldMasterIdLst>
     <p:sldMasterId id="2147483648" r:id="rId1"/>
   </p:sldMasterIdLst>
+  <p:notesMasterIdLst>
+    <p:notesMasterId r:id="rId18"/>
+  </p:notesMasterIdLst>
   <p:sldIdLst>
     <p:sldId id="256" r:id="rId2"/>
     <p:sldId id="257" r:id="rId3"/>
@@ -22,9 +25,6 @@
     <p:sldId id="270" r:id="rId16"/>
     <p:sldId id="271" r:id="rId17"/>
   </p:sldIdLst>
-  <p:notesMasterIdLst>
-    <p:notesMasterId r:id="rId18"/>
-  </p:notesMasterIdLst>
   <p:sldSz cx="12192000" cy="6858000"/>
   <p:notesSz cx="6858000" cy="12192000"/>
   <p:defaultTextStyle>
@@ -119,6 +119,11 @@
       </a:defRPr>
     </a:lvl9pPr>
   </p:defaultTextStyle>
+  <p:extLst>
+    <p:ext uri="{EFAFB233-063F-42B5-8137-9DF3F51BA10A}">
+      <p15:sldGuideLst xmlns:p15="http://schemas.microsoft.com/office/powerpoint/2012/main"/>
+    </p:ext>
+  </p:extLst>
 </p:presentation>
 </file>
 
@@ -144,234 +149,10 @@
           <a:chExt cx="0" cy="0"/>
         </a:xfrm>
       </p:grpSpPr>
-      <p:sp>
-        <p:nvSpPr>
-          <p:cNvPr id="2" name="Header Placeholder 1"/>
-          <p:cNvSpPr>
-            <a:spLocks noGrp="1"/>
-          </p:cNvSpPr>
-          <p:nvPr>
-            <p:ph type="hdr" sz="quarter"/>
-          </p:nvPr>
-        </p:nvSpPr>
-        <p:spPr>
-          <a:xfrm>
-            <a:off x="0" y="0"/>
-            <a:ext cx="2971800" cy="458788"/>
-          </a:xfrm>
-          <a:prstGeom prst="rect">
-            <a:avLst/>
-          </a:prstGeom>
-        </p:spPr>
-        <p:txBody>
-          <a:bodyPr vert="horz" lIns="91440" tIns="45720" rIns="91440" bIns="45720" rtlCol="0"/>
-          <a:lstStyle>
-            <a:lvl1pPr algn="l">
-              <a:defRPr sz="1200"/>
-            </a:lvl1pPr>
-          </a:lstStyle>
-          <a:p>
-            <a:endParaRPr lang="en-US"/>
-          </a:p>
-        </p:txBody>
-      </p:sp>
-      <p:sp>
-        <p:nvSpPr>
-          <p:cNvPr id="3" name="Date Placeholder 2"/>
-          <p:cNvSpPr>
-            <a:spLocks noGrp="1"/>
-          </p:cNvSpPr>
-          <p:nvPr>
-            <p:ph type="dt" idx="1"/>
-          </p:nvPr>
-        </p:nvSpPr>
-        <p:spPr>
-          <a:xfrm>
-            <a:off x="3884613" y="0"/>
-            <a:ext cx="2971800" cy="458788"/>
-          </a:xfrm>
-          <a:prstGeom prst="rect">
-            <a:avLst/>
-          </a:prstGeom>
-        </p:spPr>
-        <p:txBody>
-          <a:bodyPr vert="horz" lIns="91440" tIns="45720" rIns="91440" bIns="45720" rtlCol="0"/>
-          <a:lstStyle>
-            <a:lvl1pPr algn="r">
-              <a:defRPr sz="1200"/>
-            </a:lvl1pPr>
-          </a:lstStyle>
-          <a:p>
-            <a:fld id="{5282F153-3F37-0F45-9E97-73ACFA13230C}" type="datetimeFigureOut">
-              <a:rPr lang="en-US"/>
-              <a:t>7/23/19</a:t>
-            </a:fld>
-            <a:endParaRPr lang="en-US"/>
-          </a:p>
-        </p:txBody>
-      </p:sp>
-      <p:sp>
-        <p:nvSpPr>
-          <p:cNvPr id="4" name="Slide Image Placeholder 3"/>
-          <p:cNvSpPr>
-            <a:spLocks noGrp="1" noRot="1" noChangeAspect="1"/>
-          </p:cNvSpPr>
-          <p:nvPr>
-            <p:ph type="sldImg" idx="2"/>
-          </p:nvPr>
-        </p:nvSpPr>
-        <p:spPr>
-          <a:xfrm>
-            <a:off x="685800" y="1143000"/>
-            <a:ext cx="5486400" cy="3086100"/>
-          </a:xfrm>
-          <a:prstGeom prst="rect">
-            <a:avLst/>
-          </a:prstGeom>
-          <a:noFill/>
-          <a:ln w="12700">
-            <a:solidFill>
-              <a:prstClr val="black"/>
-            </a:solidFill>
-          </a:ln>
-        </p:spPr>
-        <p:txBody>
-          <a:bodyPr vert="horz" lIns="91440" tIns="45720" rIns="91440" bIns="45720" rtlCol="0" anchor="ctr"/>
-          <a:lstStyle/>
-          <a:p>
-            <a:endParaRPr lang="en-US"/>
-          </a:p>
-        </p:txBody>
-      </p:sp>
-      <p:sp>
-        <p:nvSpPr>
-          <p:cNvPr id="5" name="Notes Placeholder 4"/>
-          <p:cNvSpPr>
-            <a:spLocks noGrp="1"/>
-          </p:cNvSpPr>
-          <p:nvPr>
-            <p:ph type="body" sz="quarter" idx="3"/>
-          </p:nvPr>
-        </p:nvSpPr>
-        <p:spPr>
-          <a:xfrm>
-            <a:off x="685800" y="4400550"/>
-            <a:ext cx="5486400" cy="3600450"/>
-          </a:xfrm>
-          <a:prstGeom prst="rect">
-            <a:avLst/>
-          </a:prstGeom>
-        </p:spPr>
-        <p:txBody>
-          <a:bodyPr vert="horz" lIns="91440" tIns="45720" rIns="91440" bIns="45720" rtlCol="0"/>
-          <a:lstStyle/>
-          <a:p>
-            <a:pPr lvl="0"/>
-            <a:r>
-              <a:rPr lang="en-US"/>
-              <a:t>Click to edit Master text styles</a:t>
-            </a:r>
-          </a:p>
-          <a:p>
-            <a:pPr lvl="1"/>
-            <a:r>
-              <a:rPr lang="en-US"/>
-              <a:t>Second level</a:t>
-            </a:r>
-          </a:p>
-          <a:p>
-            <a:pPr lvl="2"/>
-            <a:r>
-              <a:rPr lang="en-US"/>
-              <a:t>Third level</a:t>
-            </a:r>
-          </a:p>
-          <a:p>
-            <a:pPr lvl="3"/>
-            <a:r>
-              <a:rPr lang="en-US"/>
-              <a:t>Fourth level</a:t>
-            </a:r>
-          </a:p>
-          <a:p>
-            <a:pPr lvl="4"/>
-            <a:r>
-              <a:rPr lang="en-US"/>
-              <a:t>Fifth level</a:t>
-            </a:r>
-          </a:p>
-        </p:txBody>
-      </p:sp>
-      <p:sp>
-        <p:nvSpPr>
-          <p:cNvPr id="6" name="Footer Placeholder 5"/>
-          <p:cNvSpPr>
-            <a:spLocks noGrp="1"/>
-          </p:cNvSpPr>
-          <p:nvPr>
-            <p:ph type="ftr" sz="quarter" idx="4"/>
-          </p:nvPr>
-        </p:nvSpPr>
-        <p:spPr>
-          <a:xfrm>
-            <a:off x="0" y="8685213"/>
-            <a:ext cx="2971800" cy="458787"/>
-          </a:xfrm>
-          <a:prstGeom prst="rect">
-            <a:avLst/>
-          </a:prstGeom>
-        </p:spPr>
-        <p:txBody>
-          <a:bodyPr vert="horz" lIns="91440" tIns="45720" rIns="91440" bIns="45720" rtlCol="0" anchor="b"/>
-          <a:lstStyle>
-            <a:lvl1pPr algn="l">
-              <a:defRPr sz="1200"/>
-            </a:lvl1pPr>
-          </a:lstStyle>
-          <a:p>
-            <a:endParaRPr lang="en-US"/>
-          </a:p>
-        </p:txBody>
-      </p:sp>
-      <p:sp>
-        <p:nvSpPr>
-          <p:cNvPr id="7" name="Slide Number Placeholder 6"/>
-          <p:cNvSpPr>
-            <a:spLocks noGrp="1"/>
-          </p:cNvSpPr>
-          <p:nvPr>
-            <p:ph type="sldNum" sz="quarter" idx="5"/>
-          </p:nvPr>
-        </p:nvSpPr>
-        <p:spPr>
-          <a:xfrm>
-            <a:off x="3884613" y="8685213"/>
-            <a:ext cx="2971800" cy="458787"/>
-          </a:xfrm>
-          <a:prstGeom prst="rect">
-            <a:avLst/>
-          </a:prstGeom>
-        </p:spPr>
-        <p:txBody>
-          <a:bodyPr vert="horz" lIns="91440" tIns="45720" rIns="91440" bIns="45720" rtlCol="0" anchor="b"/>
-          <a:lstStyle>
-            <a:lvl1pPr algn="r">
-              <a:defRPr sz="1200"/>
-            </a:lvl1pPr>
-          </a:lstStyle>
-          <a:p>
-            <a:fld id="{CE5E9CC1-C706-0F49-92D6-E571CC5EEA8F}" type="slidenum">
-              <a:rPr lang="en-US"/>
-              <a:t>‹#›</a:t>
-            </a:fld>
-            <a:endParaRPr lang="en-US"/>
-          </a:p>
-        </p:txBody>
-      </p:sp>
     </p:spTree>
     <p:extLst>
       <p:ext uri="{BB962C8B-B14F-4D97-AF65-F5344CB8AC3E}">
-        <p14:creationId xmlns:p14="http://schemas.microsoft.com/office/powerpoint/2010/main" val="1024086991"/>
+        <p14:creationId xmlns:p14="http://schemas.microsoft.com/office/powerpoint/2010/main" val="253843251"/>
       </p:ext>
     </p:extLst>
   </p:cSld>
@@ -515,10 +296,6 @@
           <a:bodyPr/>
           <a:lstStyle/>
           <a:p>
-            <a:r>
-              <a:rPr lang="en-US" dirty="0"/>
-              <a:t/>
-            </a:r>
             <a:endParaRPr lang="en-US" dirty="0"/>
           </a:p>
         </p:txBody>
@@ -603,10 +380,6 @@
           <a:bodyPr/>
           <a:lstStyle/>
           <a:p>
-            <a:r>
-              <a:rPr lang="en-US" dirty="0"/>
-              <a:t/>
-            </a:r>
             <a:endParaRPr lang="en-US" dirty="0"/>
           </a:p>
         </p:txBody>
@@ -691,10 +464,6 @@
           <a:bodyPr/>
           <a:lstStyle/>
           <a:p>
-            <a:r>
-              <a:rPr lang="en-US" dirty="0"/>
-              <a:t/>
-            </a:r>
             <a:endParaRPr lang="en-US" dirty="0"/>
           </a:p>
         </p:txBody>
@@ -779,10 +548,6 @@
           <a:bodyPr/>
           <a:lstStyle/>
           <a:p>
-            <a:r>
-              <a:rPr lang="en-US" dirty="0"/>
-              <a:t/>
-            </a:r>
             <a:endParaRPr lang="en-US" dirty="0"/>
           </a:p>
         </p:txBody>
@@ -867,10 +632,6 @@
           <a:bodyPr/>
           <a:lstStyle/>
           <a:p>
-            <a:r>
-              <a:rPr lang="en-US" dirty="0"/>
-              <a:t/>
-            </a:r>
             <a:endParaRPr lang="en-US" dirty="0"/>
           </a:p>
         </p:txBody>
@@ -955,10 +716,6 @@
           <a:bodyPr/>
           <a:lstStyle/>
           <a:p>
-            <a:r>
-              <a:rPr lang="en-US" dirty="0"/>
-              <a:t/>
-            </a:r>
             <a:endParaRPr lang="en-US" dirty="0"/>
           </a:p>
         </p:txBody>
@@ -1043,10 +800,6 @@
           <a:bodyPr/>
           <a:lstStyle/>
           <a:p>
-            <a:r>
-              <a:rPr lang="en-US" dirty="0"/>
-              <a:t/>
-            </a:r>
             <a:endParaRPr lang="en-US" dirty="0"/>
           </a:p>
         </p:txBody>
@@ -1131,10 +884,6 @@
           <a:bodyPr/>
           <a:lstStyle/>
           <a:p>
-            <a:r>
-              <a:rPr lang="en-US" dirty="0"/>
-              <a:t/>
-            </a:r>
             <a:endParaRPr lang="en-US" dirty="0"/>
           </a:p>
         </p:txBody>
@@ -1219,10 +968,6 @@
           <a:bodyPr/>
           <a:lstStyle/>
           <a:p>
-            <a:r>
-              <a:rPr lang="en-US" dirty="0"/>
-              <a:t/>
-            </a:r>
             <a:endParaRPr lang="en-US" dirty="0"/>
           </a:p>
         </p:txBody>
@@ -1307,10 +1052,6 @@
           <a:bodyPr/>
           <a:lstStyle/>
           <a:p>
-            <a:r>
-              <a:rPr lang="en-US" dirty="0"/>
-              <a:t/>
-            </a:r>
             <a:endParaRPr lang="en-US" dirty="0"/>
           </a:p>
         </p:txBody>
@@ -1395,10 +1136,6 @@
           <a:bodyPr/>
           <a:lstStyle/>
           <a:p>
-            <a:r>
-              <a:rPr lang="en-US" dirty="0"/>
-              <a:t/>
-            </a:r>
             <a:endParaRPr lang="en-US" dirty="0"/>
           </a:p>
         </p:txBody>
@@ -1483,10 +1220,6 @@
           <a:bodyPr/>
           <a:lstStyle/>
           <a:p>
-            <a:r>
-              <a:rPr lang="en-US" dirty="0"/>
-              <a:t/>
-            </a:r>
             <a:endParaRPr lang="en-US" dirty="0"/>
           </a:p>
         </p:txBody>
@@ -1571,10 +1304,6 @@
           <a:bodyPr/>
           <a:lstStyle/>
           <a:p>
-            <a:r>
-              <a:rPr lang="en-US" dirty="0"/>
-              <a:t/>
-            </a:r>
             <a:endParaRPr lang="en-US" dirty="0"/>
           </a:p>
         </p:txBody>
@@ -1659,10 +1388,6 @@
           <a:bodyPr/>
           <a:lstStyle/>
           <a:p>
-            <a:r>
-              <a:rPr lang="en-US" dirty="0"/>
-              <a:t/>
-            </a:r>
             <a:endParaRPr lang="en-US" dirty="0"/>
           </a:p>
         </p:txBody>
@@ -1747,10 +1472,6 @@
           <a:bodyPr/>
           <a:lstStyle/>
           <a:p>
-            <a:r>
-              <a:rPr lang="en-US" dirty="0"/>
-              <a:t/>
-            </a:r>
             <a:endParaRPr lang="en-US" dirty="0"/>
           </a:p>
         </p:txBody>
@@ -1835,10 +1556,6 @@
           <a:bodyPr/>
           <a:lstStyle/>
           <a:p>
-            <a:r>
-              <a:rPr lang="en-US" dirty="0"/>
-              <a:t/>
-            </a:r>
             <a:endParaRPr lang="en-US" dirty="0"/>
           </a:p>
         </p:txBody>
@@ -1912,6 +1629,11 @@
 <file path=ppt/slideMasters/slideMaster1.xml><?xml version="1.0" encoding="utf-8"?>
 <p:sldMaster xmlns:a="http://schemas.openxmlformats.org/drawingml/2006/main" xmlns:r="http://schemas.openxmlformats.org/officeDocument/2006/relationships" xmlns:p="http://schemas.openxmlformats.org/presentationml/2006/main">
   <p:cSld>
+    <p:bg>
+      <p:bgRef idx="1001">
+        <a:schemeClr val="bg1"/>
+      </p:bgRef>
+    </p:bg>
     <p:spTree>
       <p:nvGrpSpPr>
         <p:cNvPr id="1" name=""/>
@@ -2194,6 +1916,7 @@
         <a:solidFill>
           <a:srgbClr val="065A82"/>
         </a:solidFill>
+        <a:effectLst/>
       </p:bgPr>
     </p:bg>
     <p:spTree>
@@ -2234,6 +1957,13 @@
             <a:prstDash val="solid"/>
           </a:ln>
         </p:spPr>
+        <p:txBody>
+          <a:bodyPr/>
+          <a:lstStyle/>
+          <a:p>
+            <a:endParaRPr lang="it-IT"/>
+          </a:p>
+        </p:txBody>
       </p:sp>
       <p:sp>
         <p:nvSpPr>
@@ -2259,6 +1989,13 @@
             <a:prstDash val="solid"/>
           </a:ln>
         </p:spPr>
+        <p:txBody>
+          <a:bodyPr/>
+          <a:lstStyle/>
+          <a:p>
+            <a:endParaRPr lang="it-IT"/>
+          </a:p>
+        </p:txBody>
       </p:sp>
       <p:sp>
         <p:nvSpPr>
@@ -2281,7 +2018,7 @@
           <a:bodyPr wrap="square" rtlCol="0" anchor="ctr"/>
           <a:lstStyle/>
           <a:p>
-            <a:pPr algn="ctr" indent="0" marL="0">
+            <a:pPr marL="0" indent="0" algn="ctr">
               <a:buNone/>
             </a:pPr>
             <a:r>
@@ -2298,7 +2035,7 @@
             <a:endParaRPr lang="en-US" sz="4000" dirty="0"/>
           </a:p>
           <a:p>
-            <a:pPr algn="ctr" indent="0" marL="0">
+            <a:pPr marL="0" indent="0" algn="ctr">
               <a:buNone/>
             </a:pPr>
             <a:r>
@@ -2337,7 +2074,7 @@
           <a:bodyPr wrap="square" rtlCol="0" anchor="ctr"/>
           <a:lstStyle/>
           <a:p>
-            <a:pPr algn="ctr" indent="0" marL="0">
+            <a:pPr marL="0" indent="0" algn="ctr">
               <a:buNone/>
             </a:pPr>
             <a:r>
@@ -2376,7 +2113,7 @@
           <a:bodyPr wrap="square" rtlCol="0" anchor="ctr"/>
           <a:lstStyle/>
           <a:p>
-            <a:pPr algn="ctr" indent="0" marL="0">
+            <a:pPr marL="0" indent="0" algn="ctr">
               <a:buNone/>
             </a:pPr>
             <a:r>
@@ -2420,6 +2157,13 @@
             <a:prstDash val="solid"/>
           </a:ln>
         </p:spPr>
+        <p:txBody>
+          <a:bodyPr/>
+          <a:lstStyle/>
+          <a:p>
+            <a:endParaRPr lang="it-IT"/>
+          </a:p>
+        </p:txBody>
       </p:sp>
       <p:sp>
         <p:nvSpPr>
@@ -2442,7 +2186,7 @@
           <a:bodyPr wrap="square" rtlCol="0" anchor="ctr"/>
           <a:lstStyle/>
           <a:p>
-            <a:pPr algn="ctr" indent="0" marL="0">
+            <a:pPr marL="0" indent="0" algn="ctr">
               <a:buNone/>
             </a:pPr>
             <a:r>
@@ -2459,7 +2203,7 @@
             <a:endParaRPr lang="en-US" sz="2200" dirty="0"/>
           </a:p>
           <a:p>
-            <a:pPr algn="ctr" indent="0" marL="0">
+            <a:pPr marL="0" indent="0" algn="ctr">
               <a:buNone/>
             </a:pPr>
             <a:r>
@@ -2503,6 +2247,13 @@
             <a:prstDash val="solid"/>
           </a:ln>
         </p:spPr>
+        <p:txBody>
+          <a:bodyPr/>
+          <a:lstStyle/>
+          <a:p>
+            <a:endParaRPr lang="it-IT"/>
+          </a:p>
+        </p:txBody>
       </p:sp>
       <p:sp>
         <p:nvSpPr>
@@ -2525,7 +2276,7 @@
           <a:bodyPr wrap="square" rtlCol="0" anchor="ctr"/>
           <a:lstStyle/>
           <a:p>
-            <a:pPr algn="ctr" indent="0" marL="0">
+            <a:pPr marL="0" indent="0" algn="ctr">
               <a:buNone/>
             </a:pPr>
             <a:r>
@@ -2542,7 +2293,7 @@
             <a:endParaRPr lang="en-US" sz="2200" dirty="0"/>
           </a:p>
           <a:p>
-            <a:pPr algn="ctr" indent="0" marL="0">
+            <a:pPr marL="0" indent="0" algn="ctr">
               <a:buNone/>
             </a:pPr>
             <a:r>
@@ -2586,6 +2337,13 @@
             <a:prstDash val="solid"/>
           </a:ln>
         </p:spPr>
+        <p:txBody>
+          <a:bodyPr/>
+          <a:lstStyle/>
+          <a:p>
+            <a:endParaRPr lang="it-IT"/>
+          </a:p>
+        </p:txBody>
       </p:sp>
       <p:sp>
         <p:nvSpPr>
@@ -2608,7 +2366,7 @@
           <a:bodyPr wrap="square" rtlCol="0" anchor="ctr"/>
           <a:lstStyle/>
           <a:p>
-            <a:pPr algn="ctr" indent="0" marL="0">
+            <a:pPr marL="0" indent="0" algn="ctr">
               <a:buNone/>
             </a:pPr>
             <a:r>
@@ -2625,7 +2383,7 @@
             <a:endParaRPr lang="en-US" sz="2200" dirty="0"/>
           </a:p>
           <a:p>
-            <a:pPr algn="ctr" indent="0" marL="0">
+            <a:pPr marL="0" indent="0" algn="ctr">
               <a:buNone/>
             </a:pPr>
             <a:r>
@@ -2659,6 +2417,7 @@
         <a:solidFill>
           <a:srgbClr val="065A82"/>
         </a:solidFill>
+        <a:effectLst/>
       </p:bgPr>
     </p:bg>
     <p:spTree>
@@ -2701,7 +2460,10 @@
         </p:spPr>
         <p:txBody>
           <a:bodyPr/>
-          <a:p/>
+          <a:lstStyle/>
+          <a:p>
+            <a:endParaRPr/>
+          </a:p>
         </p:txBody>
       </p:sp>
       <p:sp>
@@ -2725,7 +2487,7 @@
           <a:bodyPr wrap="square" rtlCol="0" anchor="ctr"/>
           <a:lstStyle/>
           <a:p>
-            <a:pPr algn="ctr" indent="0" marL="0">
+            <a:pPr marL="0" indent="0" algn="ctr">
               <a:buNone/>
             </a:pPr>
             <a:r>
@@ -2769,7 +2531,10 @@
         </p:spPr>
         <p:txBody>
           <a:bodyPr/>
-          <a:p/>
+          <a:lstStyle/>
+          <a:p>
+            <a:endParaRPr/>
+          </a:p>
         </p:txBody>
       </p:sp>
       <p:sp>
@@ -2793,7 +2558,7 @@
           <a:bodyPr wrap="square" rtlCol="0" anchor="ctr"/>
           <a:lstStyle/>
           <a:p>
-            <a:pPr algn="ctr" indent="0" marL="0">
+            <a:pPr marL="0" indent="0" algn="ctr">
               <a:buNone/>
             </a:pPr>
             <a:r>
@@ -2827,6 +2592,7 @@
         <a:solidFill>
           <a:srgbClr val="FFFFFF"/>
         </a:solidFill>
+        <a:effectLst/>
       </p:bgPr>
     </p:bg>
     <p:spTree>
@@ -2867,6 +2633,13 @@
             <a:prstDash val="solid"/>
           </a:ln>
         </p:spPr>
+        <p:txBody>
+          <a:bodyPr/>
+          <a:lstStyle/>
+          <a:p>
+            <a:endParaRPr lang="it-IT"/>
+          </a:p>
+        </p:txBody>
       </p:sp>
       <p:sp>
         <p:nvSpPr>
@@ -2889,7 +2662,7 @@
           <a:bodyPr wrap="square" rtlCol="0" anchor="ctr"/>
           <a:lstStyle/>
           <a:p>
-            <a:pPr indent="0" marL="0">
+            <a:pPr marL="0" indent="0">
               <a:buNone/>
             </a:pPr>
             <a:r>
@@ -2931,6 +2704,13 @@
             <a:prstDash val="solid"/>
           </a:ln>
         </p:spPr>
+        <p:txBody>
+          <a:bodyPr/>
+          <a:lstStyle/>
+          <a:p>
+            <a:endParaRPr lang="it-IT"/>
+          </a:p>
+        </p:txBody>
       </p:sp>
       <p:sp>
         <p:nvSpPr>
@@ -2956,6 +2736,13 @@
             <a:prstDash val="solid"/>
           </a:ln>
         </p:spPr>
+        <p:txBody>
+          <a:bodyPr/>
+          <a:lstStyle/>
+          <a:p>
+            <a:endParaRPr lang="it-IT"/>
+          </a:p>
+        </p:txBody>
       </p:sp>
       <p:sp>
         <p:nvSpPr>
@@ -2981,6 +2768,13 @@
             <a:prstDash val="solid"/>
           </a:ln>
         </p:spPr>
+        <p:txBody>
+          <a:bodyPr/>
+          <a:lstStyle/>
+          <a:p>
+            <a:endParaRPr lang="it-IT"/>
+          </a:p>
+        </p:txBody>
       </p:sp>
       <p:sp>
         <p:nvSpPr>
@@ -3003,7 +2797,7 @@
           <a:bodyPr wrap="square" rtlCol="0" anchor="ctr"/>
           <a:lstStyle/>
           <a:p>
-            <a:pPr algn="ctr" indent="0" marL="0">
+            <a:pPr marL="0" indent="0" algn="ctr">
               <a:buNone/>
             </a:pPr>
             <a:r>
@@ -3042,7 +2836,7 @@
           <a:bodyPr wrap="square" rtlCol="0" anchor="ctr"/>
           <a:lstStyle/>
           <a:p>
-            <a:pPr algn="ctr" indent="0" marL="0">
+            <a:pPr marL="0" indent="0" algn="ctr">
               <a:buNone/>
             </a:pPr>
             <a:r>
@@ -3081,7 +2875,7 @@
           <a:bodyPr wrap="square" rtlCol="0" anchor="t"/>
           <a:lstStyle/>
           <a:p>
-            <a:pPr indent="0" marL="0">
+            <a:pPr marL="0" indent="0">
               <a:buNone/>
             </a:pPr>
             <a:r>
@@ -3123,6 +2917,13 @@
             <a:prstDash val="solid"/>
           </a:ln>
         </p:spPr>
+        <p:txBody>
+          <a:bodyPr/>
+          <a:lstStyle/>
+          <a:p>
+            <a:endParaRPr lang="it-IT"/>
+          </a:p>
+        </p:txBody>
       </p:sp>
       <p:sp>
         <p:nvSpPr>
@@ -3148,6 +2949,13 @@
             <a:prstDash val="solid"/>
           </a:ln>
         </p:spPr>
+        <p:txBody>
+          <a:bodyPr/>
+          <a:lstStyle/>
+          <a:p>
+            <a:endParaRPr lang="it-IT"/>
+          </a:p>
+        </p:txBody>
       </p:sp>
       <p:sp>
         <p:nvSpPr>
@@ -3173,6 +2981,13 @@
             <a:prstDash val="solid"/>
           </a:ln>
         </p:spPr>
+        <p:txBody>
+          <a:bodyPr/>
+          <a:lstStyle/>
+          <a:p>
+            <a:endParaRPr lang="it-IT"/>
+          </a:p>
+        </p:txBody>
       </p:sp>
       <p:sp>
         <p:nvSpPr>
@@ -3195,7 +3010,7 @@
           <a:bodyPr wrap="square" rtlCol="0" anchor="ctr"/>
           <a:lstStyle/>
           <a:p>
-            <a:pPr algn="ctr" indent="0" marL="0">
+            <a:pPr marL="0" indent="0" algn="ctr">
               <a:buNone/>
             </a:pPr>
             <a:r>
@@ -3234,7 +3049,7 @@
           <a:bodyPr wrap="square" rtlCol="0" anchor="ctr"/>
           <a:lstStyle/>
           <a:p>
-            <a:pPr algn="ctr" indent="0" marL="0">
+            <a:pPr marL="0" indent="0" algn="ctr">
               <a:buNone/>
             </a:pPr>
             <a:r>
@@ -3273,7 +3088,7 @@
           <a:bodyPr wrap="square" rtlCol="0" anchor="t"/>
           <a:lstStyle/>
           <a:p>
-            <a:pPr indent="0" marL="0">
+            <a:pPr marL="0" indent="0">
               <a:buNone/>
             </a:pPr>
             <a:r>
@@ -3315,6 +3130,13 @@
             <a:prstDash val="solid"/>
           </a:ln>
         </p:spPr>
+        <p:txBody>
+          <a:bodyPr/>
+          <a:lstStyle/>
+          <a:p>
+            <a:endParaRPr lang="it-IT"/>
+          </a:p>
+        </p:txBody>
       </p:sp>
       <p:sp>
         <p:nvSpPr>
@@ -3340,6 +3162,13 @@
             <a:prstDash val="solid"/>
           </a:ln>
         </p:spPr>
+        <p:txBody>
+          <a:bodyPr/>
+          <a:lstStyle/>
+          <a:p>
+            <a:endParaRPr lang="it-IT"/>
+          </a:p>
+        </p:txBody>
       </p:sp>
       <p:sp>
         <p:nvSpPr>
@@ -3365,6 +3194,13 @@
             <a:prstDash val="solid"/>
           </a:ln>
         </p:spPr>
+        <p:txBody>
+          <a:bodyPr/>
+          <a:lstStyle/>
+          <a:p>
+            <a:endParaRPr lang="it-IT"/>
+          </a:p>
+        </p:txBody>
       </p:sp>
       <p:sp>
         <p:nvSpPr>
@@ -3387,7 +3223,7 @@
           <a:bodyPr wrap="square" rtlCol="0" anchor="ctr"/>
           <a:lstStyle/>
           <a:p>
-            <a:pPr algn="ctr" indent="0" marL="0">
+            <a:pPr marL="0" indent="0" algn="ctr">
               <a:buNone/>
             </a:pPr>
             <a:r>
@@ -3426,7 +3262,7 @@
           <a:bodyPr wrap="square" rtlCol="0" anchor="ctr"/>
           <a:lstStyle/>
           <a:p>
-            <a:pPr algn="ctr" indent="0" marL="0">
+            <a:pPr marL="0" indent="0" algn="ctr">
               <a:buNone/>
             </a:pPr>
             <a:r>
@@ -3465,7 +3301,7 @@
           <a:bodyPr wrap="square" rtlCol="0" anchor="t"/>
           <a:lstStyle/>
           <a:p>
-            <a:pPr indent="0" marL="0">
+            <a:pPr marL="0" indent="0">
               <a:buNone/>
             </a:pPr>
             <a:r>
@@ -3507,6 +3343,13 @@
             <a:prstDash val="solid"/>
           </a:ln>
         </p:spPr>
+        <p:txBody>
+          <a:bodyPr/>
+          <a:lstStyle/>
+          <a:p>
+            <a:endParaRPr lang="it-IT"/>
+          </a:p>
+        </p:txBody>
       </p:sp>
       <p:sp>
         <p:nvSpPr>
@@ -3532,6 +3375,13 @@
             <a:prstDash val="solid"/>
           </a:ln>
         </p:spPr>
+        <p:txBody>
+          <a:bodyPr/>
+          <a:lstStyle/>
+          <a:p>
+            <a:endParaRPr lang="it-IT"/>
+          </a:p>
+        </p:txBody>
       </p:sp>
       <p:sp>
         <p:nvSpPr>
@@ -3557,6 +3407,13 @@
             <a:prstDash val="solid"/>
           </a:ln>
         </p:spPr>
+        <p:txBody>
+          <a:bodyPr/>
+          <a:lstStyle/>
+          <a:p>
+            <a:endParaRPr lang="it-IT"/>
+          </a:p>
+        </p:txBody>
       </p:sp>
       <p:sp>
         <p:nvSpPr>
@@ -3579,7 +3436,7 @@
           <a:bodyPr wrap="square" rtlCol="0" anchor="ctr"/>
           <a:lstStyle/>
           <a:p>
-            <a:pPr algn="ctr" indent="0" marL="0">
+            <a:pPr marL="0" indent="0" algn="ctr">
               <a:buNone/>
             </a:pPr>
             <a:r>
@@ -3618,7 +3475,7 @@
           <a:bodyPr wrap="square" rtlCol="0" anchor="ctr"/>
           <a:lstStyle/>
           <a:p>
-            <a:pPr algn="ctr" indent="0" marL="0">
+            <a:pPr marL="0" indent="0" algn="ctr">
               <a:buNone/>
             </a:pPr>
             <a:r>
@@ -3657,7 +3514,7 @@
           <a:bodyPr wrap="square" rtlCol="0" anchor="t"/>
           <a:lstStyle/>
           <a:p>
-            <a:pPr indent="0" marL="0">
+            <a:pPr marL="0" indent="0">
               <a:buNone/>
             </a:pPr>
             <a:r>
@@ -3699,6 +3556,13 @@
             <a:prstDash val="solid"/>
           </a:ln>
         </p:spPr>
+        <p:txBody>
+          <a:bodyPr/>
+          <a:lstStyle/>
+          <a:p>
+            <a:endParaRPr lang="it-IT"/>
+          </a:p>
+        </p:txBody>
       </p:sp>
       <p:sp>
         <p:nvSpPr>
@@ -3721,7 +3585,7 @@
           <a:bodyPr wrap="square" rtlCol="0" anchor="ctr"/>
           <a:lstStyle/>
           <a:p>
-            <a:pPr algn="ctr" indent="0" marL="0">
+            <a:pPr marL="0" indent="0" algn="ctr">
               <a:buNone/>
             </a:pPr>
             <a:r>
@@ -3763,6 +3627,13 @@
             <a:prstDash val="solid"/>
           </a:ln>
         </p:spPr>
+        <p:txBody>
+          <a:bodyPr/>
+          <a:lstStyle/>
+          <a:p>
+            <a:endParaRPr lang="it-IT"/>
+          </a:p>
+        </p:txBody>
       </p:sp>
       <p:sp>
         <p:nvSpPr>
@@ -3785,7 +3656,7 @@
           <a:bodyPr wrap="square" rtlCol="0" anchor="ctr"/>
           <a:lstStyle/>
           <a:p>
-            <a:pPr algn="ctr" indent="0" marL="0">
+            <a:pPr marL="0" indent="0" algn="ctr">
               <a:buNone/>
             </a:pPr>
             <a:r>
@@ -3827,6 +3698,13 @@
             <a:prstDash val="solid"/>
           </a:ln>
         </p:spPr>
+        <p:txBody>
+          <a:bodyPr/>
+          <a:lstStyle/>
+          <a:p>
+            <a:endParaRPr lang="it-IT"/>
+          </a:p>
+        </p:txBody>
       </p:sp>
       <p:sp>
         <p:nvSpPr>
@@ -3849,7 +3727,7 @@
           <a:bodyPr wrap="square" rtlCol="0" anchor="ctr"/>
           <a:lstStyle/>
           <a:p>
-            <a:pPr algn="ctr" indent="0" marL="0">
+            <a:pPr marL="0" indent="0" algn="ctr">
               <a:buNone/>
             </a:pPr>
             <a:r>
@@ -3891,6 +3769,13 @@
             <a:prstDash val="solid"/>
           </a:ln>
         </p:spPr>
+        <p:txBody>
+          <a:bodyPr/>
+          <a:lstStyle/>
+          <a:p>
+            <a:endParaRPr lang="it-IT"/>
+          </a:p>
+        </p:txBody>
       </p:sp>
       <p:sp>
         <p:nvSpPr>
@@ -3913,7 +3798,7 @@
           <a:bodyPr wrap="square" rtlCol="0" anchor="ctr"/>
           <a:lstStyle/>
           <a:p>
-            <a:pPr algn="ctr" indent="0" marL="0">
+            <a:pPr marL="0" indent="0" algn="ctr">
               <a:buNone/>
             </a:pPr>
             <a:r>
@@ -3955,6 +3840,13 @@
             <a:prstDash val="solid"/>
           </a:ln>
         </p:spPr>
+        <p:txBody>
+          <a:bodyPr/>
+          <a:lstStyle/>
+          <a:p>
+            <a:endParaRPr lang="it-IT"/>
+          </a:p>
+        </p:txBody>
       </p:sp>
       <p:sp>
         <p:nvSpPr>
@@ -3977,7 +3869,7 @@
           <a:bodyPr wrap="square" rtlCol="0" anchor="ctr"/>
           <a:lstStyle/>
           <a:p>
-            <a:pPr algn="ctr" indent="0" marL="0">
+            <a:pPr marL="0" indent="0" algn="ctr">
               <a:buNone/>
             </a:pPr>
             <a:r>
@@ -4011,6 +3903,7 @@
         <a:solidFill>
           <a:srgbClr val="FFFFFF"/>
         </a:solidFill>
+        <a:effectLst/>
       </p:bgPr>
     </p:bg>
     <p:spTree>
@@ -4051,6 +3944,13 @@
             <a:prstDash val="solid"/>
           </a:ln>
         </p:spPr>
+        <p:txBody>
+          <a:bodyPr/>
+          <a:lstStyle/>
+          <a:p>
+            <a:endParaRPr lang="it-IT"/>
+          </a:p>
+        </p:txBody>
       </p:sp>
       <p:sp>
         <p:nvSpPr>
@@ -4073,7 +3973,7 @@
           <a:bodyPr wrap="square" rtlCol="0" anchor="ctr"/>
           <a:lstStyle/>
           <a:p>
-            <a:pPr indent="0" marL="0">
+            <a:pPr marL="0" indent="0">
               <a:buNone/>
             </a:pPr>
             <a:r>
@@ -4093,14 +3993,14 @@
       </p:sp>
       <p:pic>
         <p:nvPicPr>
-          <p:cNvPr id="4" name="Image 0" descr="/Users/danieleuras/Documents/GitHub/hhe-labsardinia/data/figures/hazard_index_map.png">    </p:cNvPr>
+          <p:cNvPr id="4" name="Image 0" descr="/Users/danieleuras/Documents/GitHub/hhe-labsardinia/data/figures/hazard_index_map.png"/>
           <p:cNvPicPr>
             <a:picLocks noChangeAspect="1"/>
           </p:cNvPicPr>
           <p:nvPr/>
         </p:nvPicPr>
         <p:blipFill>
-          <a:blip r:embed="rId1"/>
+          <a:blip r:embed="rId3"/>
           <a:stretch>
             <a:fillRect/>
           </a:stretch>
@@ -4139,6 +4039,13 @@
             <a:prstDash val="solid"/>
           </a:ln>
         </p:spPr>
+        <p:txBody>
+          <a:bodyPr/>
+          <a:lstStyle/>
+          <a:p>
+            <a:endParaRPr lang="it-IT"/>
+          </a:p>
+        </p:txBody>
       </p:sp>
       <p:sp>
         <p:nvSpPr>
@@ -4161,7 +4068,7 @@
           <a:bodyPr wrap="square" rtlCol="0" anchor="ctr"/>
           <a:lstStyle/>
           <a:p>
-            <a:pPr algn="ctr" indent="0" marL="0">
+            <a:pPr marL="0" indent="0" algn="ctr">
               <a:buNone/>
             </a:pPr>
             <a:r>
@@ -4195,6 +4102,7 @@
         <a:solidFill>
           <a:srgbClr val="FFFFFF"/>
         </a:solidFill>
+        <a:effectLst/>
       </p:bgPr>
     </p:bg>
     <p:spTree>
@@ -4235,6 +4143,13 @@
             <a:prstDash val="solid"/>
           </a:ln>
         </p:spPr>
+        <p:txBody>
+          <a:bodyPr/>
+          <a:lstStyle/>
+          <a:p>
+            <a:endParaRPr lang="it-IT"/>
+          </a:p>
+        </p:txBody>
       </p:sp>
       <p:sp>
         <p:nvSpPr>
@@ -4257,7 +4172,7 @@
           <a:bodyPr wrap="square" rtlCol="0" anchor="ctr"/>
           <a:lstStyle/>
           <a:p>
-            <a:pPr indent="0" marL="0">
+            <a:pPr marL="0" indent="0">
               <a:buNone/>
             </a:pPr>
             <a:r>
@@ -4277,92 +4192,28 @@
       </p:sp>
       <p:pic>
         <p:nvPicPr>
-          <p:cNvPr id="4" name="Image 0" descr="/Users/danieleuras/Documents/GitHub/hhe-labsardinia/data/figures/hazard_temporal_2x2.png">    </p:cNvPr>
+          <p:cNvPr id="4" name="Image 0" descr="/Users/danieleuras/Documents/GitHub/hhe-labsardinia/data/figures/hazard_temporal_2x2.png"/>
           <p:cNvPicPr>
             <a:picLocks noChangeAspect="1"/>
           </p:cNvPicPr>
           <p:nvPr/>
         </p:nvPicPr>
         <p:blipFill>
-          <a:blip r:embed="rId1"/>
+          <a:blip r:embed="rId3"/>
           <a:stretch>
             <a:fillRect/>
           </a:stretch>
         </p:blipFill>
         <p:spPr>
           <a:xfrm>
-            <a:off x="274320" y="777240"/>
-            <a:ext cx="11612880" cy="5074920"/>
+            <a:off x="2596580" y="640080"/>
+            <a:ext cx="6998839" cy="6217920"/>
           </a:xfrm>
           <a:prstGeom prst="rect">
             <a:avLst/>
           </a:prstGeom>
         </p:spPr>
       </p:pic>
-      <p:sp>
-        <p:nvSpPr>
-          <p:cNvPr id="5" name="Shape 2"/>
-          <p:cNvSpPr/>
-          <p:nvPr/>
-        </p:nvSpPr>
-        <p:spPr>
-          <a:xfrm>
-            <a:off x="274320" y="5943600"/>
-            <a:ext cx="11612880" cy="685800"/>
-          </a:xfrm>
-          <a:prstGeom prst="rect">
-            <a:avLst/>
-          </a:prstGeom>
-          <a:solidFill>
-            <a:srgbClr val="FFF3CD"/>
-          </a:solidFill>
-          <a:ln w="25400">
-            <a:solidFill>
-              <a:srgbClr val="F39C12"/>
-            </a:solidFill>
-            <a:prstDash val="solid"/>
-          </a:ln>
-        </p:spPr>
-      </p:sp>
-      <p:sp>
-        <p:nvSpPr>
-          <p:cNvPr id="6" name="Text 3"/>
-          <p:cNvSpPr/>
-          <p:nvPr/>
-        </p:nvSpPr>
-        <p:spPr>
-          <a:xfrm>
-            <a:off x="274320" y="5943600"/>
-            <a:ext cx="11612880" cy="685800"/>
-          </a:xfrm>
-          <a:prstGeom prst="rect">
-            <a:avLst/>
-          </a:prstGeom>
-          <a:noFill/>
-          <a:ln/>
-        </p:spPr>
-        <p:txBody>
-          <a:bodyPr wrap="square" rtlCol="0" anchor="ctr"/>
-          <a:lstStyle/>
-          <a:p>
-            <a:pPr algn="ctr" indent="0" marL="0">
-              <a:buNone/>
-            </a:pPr>
-            <a:r>
-              <a:rPr lang="en-US" sz="1200" dirty="0">
-                <a:solidFill>
-                  <a:srgbClr val="856404"/>
-                </a:solidFill>
-                <a:latin typeface="Calibri" pitchFamily="34" charset="0"/>
-                <a:ea typeface="Calibri" pitchFamily="34" charset="-122"/>
-                <a:cs typeface="Calibri" pitchFamily="34" charset="-120"/>
-              </a:rPr>
-              <a:t>⚠  Globally normalized scores — colors comparable across years.  2020: beach compartment only.  2021–2023: beach + floating composite.</a:t>
-            </a:r>
-            <a:endParaRPr lang="en-US" sz="1200" dirty="0"/>
-          </a:p>
-        </p:txBody>
-      </p:sp>
     </p:spTree>
   </p:cSld>
   <p:clrMapOvr>
@@ -4379,6 +4230,7 @@
         <a:solidFill>
           <a:srgbClr val="FFFFFF"/>
         </a:solidFill>
+        <a:effectLst/>
       </p:bgPr>
     </p:bg>
     <p:spTree>
@@ -4419,6 +4271,13 @@
             <a:prstDash val="solid"/>
           </a:ln>
         </p:spPr>
+        <p:txBody>
+          <a:bodyPr/>
+          <a:lstStyle/>
+          <a:p>
+            <a:endParaRPr lang="it-IT"/>
+          </a:p>
+        </p:txBody>
       </p:sp>
       <p:sp>
         <p:nvSpPr>
@@ -4441,7 +4300,7 @@
           <a:bodyPr wrap="square" rtlCol="0" anchor="ctr"/>
           <a:lstStyle/>
           <a:p>
-            <a:pPr indent="0" marL="0">
+            <a:pPr marL="0" indent="0">
               <a:buNone/>
             </a:pPr>
             <a:r>
@@ -4483,6 +4342,13 @@
             <a:prstDash val="solid"/>
           </a:ln>
         </p:spPr>
+        <p:txBody>
+          <a:bodyPr/>
+          <a:lstStyle/>
+          <a:p>
+            <a:endParaRPr lang="it-IT"/>
+          </a:p>
+        </p:txBody>
       </p:sp>
       <p:sp>
         <p:nvSpPr>
@@ -4508,6 +4374,13 @@
             <a:prstDash val="solid"/>
           </a:ln>
         </p:spPr>
+        <p:txBody>
+          <a:bodyPr/>
+          <a:lstStyle/>
+          <a:p>
+            <a:endParaRPr lang="it-IT"/>
+          </a:p>
+        </p:txBody>
       </p:sp>
       <p:sp>
         <p:nvSpPr>
@@ -4530,7 +4403,7 @@
           <a:bodyPr wrap="square" rtlCol="0" anchor="ctr"/>
           <a:lstStyle/>
           <a:p>
-            <a:pPr algn="ctr" indent="0" marL="0">
+            <a:pPr marL="0" indent="0" algn="ctr">
               <a:buNone/>
             </a:pPr>
             <a:r>
@@ -4569,7 +4442,7 @@
           <a:bodyPr wrap="square" rtlCol="0" anchor="ctr"/>
           <a:lstStyle/>
           <a:p>
-            <a:pPr indent="0" marL="0">
+            <a:pPr marL="0" indent="0">
               <a:buNone/>
             </a:pPr>
             <a:r>
@@ -4608,7 +4481,7 @@
           <a:bodyPr wrap="square" rtlCol="0" anchor="ctr"/>
           <a:lstStyle/>
           <a:p>
-            <a:pPr indent="0" marL="0">
+            <a:pPr marL="0" indent="0">
               <a:buNone/>
             </a:pPr>
             <a:r>
@@ -4647,7 +4520,7 @@
           <a:bodyPr wrap="square" rtlCol="0" anchor="ctr"/>
           <a:lstStyle/>
           <a:p>
-            <a:pPr indent="0" marL="0">
+            <a:pPr marL="0" indent="0">
               <a:buNone/>
             </a:pPr>
             <a:r>
@@ -4686,7 +4559,7 @@
           <a:bodyPr wrap="square" rtlCol="0" anchor="ctr"/>
           <a:lstStyle/>
           <a:p>
-            <a:pPr indent="0" marL="0">
+            <a:pPr marL="0" indent="0">
               <a:buNone/>
             </a:pPr>
             <a:r>
@@ -4725,7 +4598,7 @@
           <a:bodyPr wrap="square" rtlCol="0" anchor="ctr"/>
           <a:lstStyle/>
           <a:p>
-            <a:pPr indent="0" marL="0">
+            <a:pPr marL="0" indent="0">
               <a:buNone/>
             </a:pPr>
             <a:r>
@@ -4767,6 +4640,13 @@
             <a:prstDash val="solid"/>
           </a:ln>
         </p:spPr>
+        <p:txBody>
+          <a:bodyPr/>
+          <a:lstStyle/>
+          <a:p>
+            <a:endParaRPr lang="it-IT"/>
+          </a:p>
+        </p:txBody>
       </p:sp>
       <p:sp>
         <p:nvSpPr>
@@ -4789,7 +4669,7 @@
           <a:bodyPr wrap="square" rtlCol="0" anchor="ctr"/>
           <a:lstStyle/>
           <a:p>
-            <a:pPr algn="ctr" indent="0" marL="0">
+            <a:pPr marL="0" indent="0" algn="ctr">
               <a:buNone/>
             </a:pPr>
             <a:r>
@@ -4828,7 +4708,7 @@
           <a:bodyPr wrap="square" rtlCol="0" anchor="ctr"/>
           <a:lstStyle/>
           <a:p>
-            <a:pPr algn="ctr" indent="0" marL="0">
+            <a:pPr marL="0" indent="0" algn="ctr">
               <a:buNone/>
             </a:pPr>
             <a:r>
@@ -4870,6 +4750,13 @@
             <a:prstDash val="solid"/>
           </a:ln>
         </p:spPr>
+        <p:txBody>
+          <a:bodyPr/>
+          <a:lstStyle/>
+          <a:p>
+            <a:endParaRPr lang="it-IT"/>
+          </a:p>
+        </p:txBody>
       </p:sp>
       <p:sp>
         <p:nvSpPr>
@@ -4895,6 +4782,13 @@
             <a:prstDash val="solid"/>
           </a:ln>
         </p:spPr>
+        <p:txBody>
+          <a:bodyPr/>
+          <a:lstStyle/>
+          <a:p>
+            <a:endParaRPr lang="it-IT"/>
+          </a:p>
+        </p:txBody>
       </p:sp>
       <p:sp>
         <p:nvSpPr>
@@ -4917,7 +4811,7 @@
           <a:bodyPr wrap="square" rtlCol="0" anchor="ctr"/>
           <a:lstStyle/>
           <a:p>
-            <a:pPr algn="ctr" indent="0" marL="0">
+            <a:pPr marL="0" indent="0" algn="ctr">
               <a:buNone/>
             </a:pPr>
             <a:r>
@@ -5159,6 +5053,13 @@
             <a:prstDash val="solid"/>
           </a:ln>
         </p:spPr>
+        <p:txBody>
+          <a:bodyPr/>
+          <a:lstStyle/>
+          <a:p>
+            <a:endParaRPr lang="it-IT"/>
+          </a:p>
+        </p:txBody>
       </p:sp>
       <p:sp>
         <p:nvSpPr>
@@ -5181,7 +5082,7 @@
           <a:bodyPr wrap="square" rtlCol="0" anchor="ctr"/>
           <a:lstStyle/>
           <a:p>
-            <a:pPr algn="ctr" indent="0" marL="0">
+            <a:pPr marL="0" indent="0" algn="ctr">
               <a:buNone/>
             </a:pPr>
             <a:r>
@@ -5220,7 +5121,7 @@
           <a:bodyPr wrap="square" rtlCol="0" anchor="ctr"/>
           <a:lstStyle/>
           <a:p>
-            <a:pPr algn="ctr" indent="0" marL="0">
+            <a:pPr marL="0" indent="0" algn="ctr">
               <a:buNone/>
             </a:pPr>
             <a:r>
@@ -5254,6 +5155,7 @@
         <a:solidFill>
           <a:srgbClr val="FFFFFF"/>
         </a:solidFill>
+        <a:effectLst/>
       </p:bgPr>
     </p:bg>
     <p:spTree>
@@ -5294,6 +5196,13 @@
             <a:prstDash val="solid"/>
           </a:ln>
         </p:spPr>
+        <p:txBody>
+          <a:bodyPr/>
+          <a:lstStyle/>
+          <a:p>
+            <a:endParaRPr lang="it-IT"/>
+          </a:p>
+        </p:txBody>
       </p:sp>
       <p:sp>
         <p:nvSpPr>
@@ -5316,7 +5225,7 @@
           <a:bodyPr wrap="square" rtlCol="0" anchor="ctr"/>
           <a:lstStyle/>
           <a:p>
-            <a:pPr indent="0" marL="0">
+            <a:pPr marL="0" indent="0">
               <a:buNone/>
             </a:pPr>
             <a:r>
@@ -5343,7 +5252,7 @@
         <p:spPr>
           <a:xfrm>
             <a:off x="457200" y="914400"/>
-            <a:ext cx="5394960" cy="5120640"/>
+            <a:ext cx="5394960" cy="1723697"/>
           </a:xfrm>
           <a:prstGeom prst="rect">
             <a:avLst/>
@@ -5358,6 +5267,13 @@
             <a:prstDash val="solid"/>
           </a:ln>
         </p:spPr>
+        <p:txBody>
+          <a:bodyPr/>
+          <a:lstStyle/>
+          <a:p>
+            <a:endParaRPr lang="it-IT"/>
+          </a:p>
+        </p:txBody>
       </p:sp>
       <p:sp>
         <p:nvSpPr>
@@ -5383,6 +5299,13 @@
             <a:prstDash val="solid"/>
           </a:ln>
         </p:spPr>
+        <p:txBody>
+          <a:bodyPr/>
+          <a:lstStyle/>
+          <a:p>
+            <a:endParaRPr lang="it-IT"/>
+          </a:p>
+        </p:txBody>
       </p:sp>
       <p:sp>
         <p:nvSpPr>
@@ -5405,7 +5328,7 @@
           <a:bodyPr wrap="square" rtlCol="0" anchor="ctr"/>
           <a:lstStyle/>
           <a:p>
-            <a:pPr indent="0" marL="0">
+            <a:pPr marL="0" indent="0">
               <a:buNone/>
             </a:pPr>
             <a:r>
@@ -5544,7 +5467,7 @@
         <p:spPr>
           <a:xfrm>
             <a:off x="6035040" y="914400"/>
-            <a:ext cx="5852160" cy="5120640"/>
+            <a:ext cx="5852160" cy="1723697"/>
           </a:xfrm>
           <a:prstGeom prst="rect">
             <a:avLst/>
@@ -5559,6 +5482,13 @@
             <a:prstDash val="solid"/>
           </a:ln>
         </p:spPr>
+        <p:txBody>
+          <a:bodyPr/>
+          <a:lstStyle/>
+          <a:p>
+            <a:endParaRPr lang="it-IT"/>
+          </a:p>
+        </p:txBody>
       </p:sp>
       <p:sp>
         <p:nvSpPr>
@@ -5584,6 +5514,13 @@
             <a:prstDash val="solid"/>
           </a:ln>
         </p:spPr>
+        <p:txBody>
+          <a:bodyPr/>
+          <a:lstStyle/>
+          <a:p>
+            <a:endParaRPr lang="it-IT"/>
+          </a:p>
+        </p:txBody>
       </p:sp>
       <p:sp>
         <p:nvSpPr>
@@ -5606,7 +5543,7 @@
           <a:bodyPr wrap="square" rtlCol="0" anchor="ctr"/>
           <a:lstStyle/>
           <a:p>
-            <a:pPr indent="0" marL="0">
+            <a:pPr marL="0" indent="0">
               <a:buNone/>
             </a:pPr>
             <a:r>
@@ -5752,6 +5689,7 @@
         <a:solidFill>
           <a:srgbClr val="065A82"/>
         </a:solidFill>
+        <a:effectLst/>
       </p:bgPr>
     </p:bg>
     <p:spTree>
@@ -5792,6 +5730,13 @@
             <a:prstDash val="solid"/>
           </a:ln>
         </p:spPr>
+        <p:txBody>
+          <a:bodyPr/>
+          <a:lstStyle/>
+          <a:p>
+            <a:endParaRPr lang="it-IT"/>
+          </a:p>
+        </p:txBody>
       </p:sp>
       <p:sp>
         <p:nvSpPr>
@@ -5817,6 +5762,13 @@
             <a:prstDash val="solid"/>
           </a:ln>
         </p:spPr>
+        <p:txBody>
+          <a:bodyPr/>
+          <a:lstStyle/>
+          <a:p>
+            <a:endParaRPr lang="it-IT"/>
+          </a:p>
+        </p:txBody>
       </p:sp>
       <p:sp>
         <p:nvSpPr>
@@ -5839,7 +5791,7 @@
           <a:bodyPr wrap="square" rtlCol="0" anchor="ctr"/>
           <a:lstStyle/>
           <a:p>
-            <a:pPr algn="ctr" indent="0" marL="0">
+            <a:pPr marL="0" indent="0" algn="ctr">
               <a:buNone/>
             </a:pPr>
             <a:r>
@@ -5881,6 +5833,13 @@
             <a:prstDash val="solid"/>
           </a:ln>
         </p:spPr>
+        <p:txBody>
+          <a:bodyPr/>
+          <a:lstStyle/>
+          <a:p>
+            <a:endParaRPr lang="it-IT"/>
+          </a:p>
+        </p:txBody>
       </p:sp>
       <p:sp>
         <p:nvSpPr>
@@ -5903,7 +5862,7 @@
           <a:bodyPr wrap="square" rtlCol="0" anchor="ctr"/>
           <a:lstStyle/>
           <a:p>
-            <a:pPr algn="ctr" indent="0" marL="0">
+            <a:pPr marL="0" indent="0" algn="ctr">
               <a:buNone/>
             </a:pPr>
             <a:r>
@@ -5942,7 +5901,7 @@
           <a:bodyPr wrap="square" rtlCol="0" anchor="ctr"/>
           <a:lstStyle/>
           <a:p>
-            <a:pPr algn="ctr" indent="0" marL="0">
+            <a:pPr marL="0" indent="0" algn="ctr">
               <a:buNone/>
             </a:pPr>
             <a:r>
@@ -5981,7 +5940,7 @@
           <a:bodyPr wrap="square" rtlCol="0" anchor="ctr"/>
           <a:lstStyle/>
           <a:p>
-            <a:pPr algn="ctr" indent="0" marL="0">
+            <a:pPr marL="0" indent="0" algn="ctr">
               <a:buNone/>
             </a:pPr>
             <a:r>
@@ -6020,7 +5979,7 @@
           <a:bodyPr wrap="square" rtlCol="0" anchor="ctr"/>
           <a:lstStyle/>
           <a:p>
-            <a:pPr algn="ctr" indent="0" marL="0">
+            <a:pPr marL="0" indent="0" algn="ctr">
               <a:buNone/>
             </a:pPr>
             <a:r>
@@ -6054,6 +6013,7 @@
         <a:solidFill>
           <a:srgbClr val="FFFFFF"/>
         </a:solidFill>
+        <a:effectLst/>
       </p:bgPr>
     </p:bg>
     <p:spTree>
@@ -6094,6 +6054,13 @@
             <a:prstDash val="solid"/>
           </a:ln>
         </p:spPr>
+        <p:txBody>
+          <a:bodyPr/>
+          <a:lstStyle/>
+          <a:p>
+            <a:endParaRPr lang="it-IT"/>
+          </a:p>
+        </p:txBody>
       </p:sp>
       <p:sp>
         <p:nvSpPr>
@@ -6116,7 +6083,7 @@
           <a:bodyPr wrap="square" rtlCol="0" anchor="ctr"/>
           <a:lstStyle/>
           <a:p>
-            <a:pPr indent="0" marL="0">
+            <a:pPr marL="0" indent="0">
               <a:buNone/>
             </a:pPr>
             <a:r>
@@ -6158,6 +6125,13 @@
             <a:prstDash val="solid"/>
           </a:ln>
         </p:spPr>
+        <p:txBody>
+          <a:bodyPr/>
+          <a:lstStyle/>
+          <a:p>
+            <a:endParaRPr lang="it-IT"/>
+          </a:p>
+        </p:txBody>
       </p:sp>
       <p:sp>
         <p:nvSpPr>
@@ -6183,6 +6157,13 @@
             <a:prstDash val="solid"/>
           </a:ln>
         </p:spPr>
+        <p:txBody>
+          <a:bodyPr/>
+          <a:lstStyle/>
+          <a:p>
+            <a:endParaRPr lang="it-IT"/>
+          </a:p>
+        </p:txBody>
       </p:sp>
       <p:sp>
         <p:nvSpPr>
@@ -6205,7 +6186,7 @@
           <a:bodyPr wrap="square" rtlCol="0" anchor="ctr"/>
           <a:lstStyle/>
           <a:p>
-            <a:pPr indent="0" marL="0">
+            <a:pPr marL="0" indent="0">
               <a:buNone/>
             </a:pPr>
             <a:r>
@@ -6222,7 +6203,7 @@
             <a:endParaRPr lang="en-US" sz="1600" dirty="0"/>
           </a:p>
           <a:p>
-            <a:pPr indent="0" marL="0">
+            <a:pPr marL="0" indent="0">
               <a:buNone/>
             </a:pPr>
             <a:r>
@@ -6264,6 +6245,13 @@
             <a:prstDash val="solid"/>
           </a:ln>
         </p:spPr>
+        <p:txBody>
+          <a:bodyPr/>
+          <a:lstStyle/>
+          <a:p>
+            <a:endParaRPr lang="it-IT"/>
+          </a:p>
+        </p:txBody>
       </p:sp>
       <p:sp>
         <p:nvSpPr>
@@ -6289,6 +6277,13 @@
             <a:prstDash val="solid"/>
           </a:ln>
         </p:spPr>
+        <p:txBody>
+          <a:bodyPr/>
+          <a:lstStyle/>
+          <a:p>
+            <a:endParaRPr lang="it-IT"/>
+          </a:p>
+        </p:txBody>
       </p:sp>
       <p:sp>
         <p:nvSpPr>
@@ -6311,7 +6306,7 @@
           <a:bodyPr wrap="square" rtlCol="0" anchor="ctr"/>
           <a:lstStyle/>
           <a:p>
-            <a:pPr algn="ctr" indent="0" marL="0">
+            <a:pPr marL="0" indent="0" algn="ctr">
               <a:buNone/>
             </a:pPr>
             <a:r>
@@ -6350,7 +6345,7 @@
           <a:bodyPr wrap="square" rtlCol="0" anchor="t"/>
           <a:lstStyle/>
           <a:p>
-            <a:pPr indent="0" marL="0">
+            <a:pPr marL="0" indent="0">
               <a:buNone/>
             </a:pPr>
             <a:r>
@@ -6367,13 +6362,13 @@
             <a:endParaRPr lang="en-US" sz="1300" dirty="0"/>
           </a:p>
           <a:p>
-            <a:pPr indent="0" marL="0">
+            <a:pPr marL="0" indent="0">
               <a:buNone/>
             </a:pPr>
             <a:endParaRPr lang="en-US" sz="1300" dirty="0"/>
           </a:p>
           <a:p>
-            <a:pPr indent="0" marL="0">
+            <a:pPr marL="0" indent="0">
               <a:buNone/>
             </a:pPr>
             <a:r>
@@ -6390,7 +6385,7 @@
             <a:endParaRPr lang="en-US" sz="1300" dirty="0"/>
           </a:p>
           <a:p>
-            <a:pPr indent="0" marL="0">
+            <a:pPr marL="0" indent="0">
               <a:buNone/>
             </a:pPr>
             <a:r>
@@ -6407,7 +6402,7 @@
             <a:endParaRPr lang="en-US" sz="1300" dirty="0"/>
           </a:p>
           <a:p>
-            <a:pPr indent="0" marL="0">
+            <a:pPr marL="0" indent="0">
               <a:buNone/>
             </a:pPr>
             <a:r>
@@ -6424,7 +6419,7 @@
             <a:endParaRPr lang="en-US" sz="1300" dirty="0"/>
           </a:p>
           <a:p>
-            <a:pPr indent="0" marL="0">
+            <a:pPr marL="0" indent="0">
               <a:buNone/>
             </a:pPr>
             <a:r>
@@ -6466,6 +6461,13 @@
             <a:prstDash val="solid"/>
           </a:ln>
         </p:spPr>
+        <p:txBody>
+          <a:bodyPr/>
+          <a:lstStyle/>
+          <a:p>
+            <a:endParaRPr lang="it-IT"/>
+          </a:p>
+        </p:txBody>
       </p:sp>
       <p:sp>
         <p:nvSpPr>
@@ -6491,6 +6493,13 @@
             <a:prstDash val="solid"/>
           </a:ln>
         </p:spPr>
+        <p:txBody>
+          <a:bodyPr/>
+          <a:lstStyle/>
+          <a:p>
+            <a:endParaRPr lang="it-IT"/>
+          </a:p>
+        </p:txBody>
       </p:sp>
       <p:sp>
         <p:nvSpPr>
@@ -6513,7 +6522,7 @@
           <a:bodyPr wrap="square" rtlCol="0" anchor="ctr"/>
           <a:lstStyle/>
           <a:p>
-            <a:pPr algn="ctr" indent="0" marL="0">
+            <a:pPr marL="0" indent="0" algn="ctr">
               <a:buNone/>
             </a:pPr>
             <a:r>
@@ -6552,7 +6561,7 @@
           <a:bodyPr wrap="square" rtlCol="0" anchor="t"/>
           <a:lstStyle/>
           <a:p>
-            <a:pPr indent="0" marL="0">
+            <a:pPr marL="0" indent="0">
               <a:buNone/>
             </a:pPr>
             <a:r>
@@ -6569,13 +6578,13 @@
             <a:endParaRPr lang="en-US" sz="1300" dirty="0"/>
           </a:p>
           <a:p>
-            <a:pPr indent="0" marL="0">
+            <a:pPr marL="0" indent="0">
               <a:buNone/>
             </a:pPr>
             <a:endParaRPr lang="en-US" sz="1300" dirty="0"/>
           </a:p>
           <a:p>
-            <a:pPr indent="0" marL="0">
+            <a:pPr marL="0" indent="0">
               <a:buNone/>
             </a:pPr>
             <a:r>
@@ -6617,6 +6626,13 @@
             <a:prstDash val="solid"/>
           </a:ln>
         </p:spPr>
+        <p:txBody>
+          <a:bodyPr/>
+          <a:lstStyle/>
+          <a:p>
+            <a:endParaRPr lang="it-IT"/>
+          </a:p>
+        </p:txBody>
       </p:sp>
       <p:sp>
         <p:nvSpPr>
@@ -6642,6 +6658,13 @@
             <a:prstDash val="solid"/>
           </a:ln>
         </p:spPr>
+        <p:txBody>
+          <a:bodyPr/>
+          <a:lstStyle/>
+          <a:p>
+            <a:endParaRPr lang="it-IT"/>
+          </a:p>
+        </p:txBody>
       </p:sp>
       <p:sp>
         <p:nvSpPr>
@@ -6664,7 +6687,7 @@
           <a:bodyPr wrap="square" rtlCol="0" anchor="ctr"/>
           <a:lstStyle/>
           <a:p>
-            <a:pPr algn="ctr" indent="0" marL="0">
+            <a:pPr marL="0" indent="0" algn="ctr">
               <a:buNone/>
             </a:pPr>
             <a:r>
@@ -6703,7 +6726,7 @@
           <a:bodyPr wrap="square" rtlCol="0" anchor="t"/>
           <a:lstStyle/>
           <a:p>
-            <a:pPr indent="0" marL="0">
+            <a:pPr marL="0" indent="0">
               <a:buNone/>
             </a:pPr>
             <a:r>
@@ -6720,13 +6743,13 @@
             <a:endParaRPr lang="en-US" sz="1300" dirty="0"/>
           </a:p>
           <a:p>
-            <a:pPr indent="0" marL="0">
+            <a:pPr marL="0" indent="0">
               <a:buNone/>
             </a:pPr>
             <a:endParaRPr lang="en-US" sz="1300" dirty="0"/>
           </a:p>
           <a:p>
-            <a:pPr indent="0" marL="0">
+            <a:pPr marL="0" indent="0">
               <a:buNone/>
             </a:pPr>
             <a:r>
@@ -6743,13 +6766,13 @@
             <a:endParaRPr lang="en-US" sz="1300" dirty="0"/>
           </a:p>
           <a:p>
-            <a:pPr indent="0" marL="0">
+            <a:pPr marL="0" indent="0">
               <a:buNone/>
             </a:pPr>
             <a:endParaRPr lang="en-US" sz="1300" dirty="0"/>
           </a:p>
           <a:p>
-            <a:pPr indent="0" marL="0">
+            <a:pPr marL="0" indent="0">
               <a:buNone/>
             </a:pPr>
             <a:r>
@@ -6766,7 +6789,7 @@
             <a:endParaRPr lang="en-US" sz="1300" dirty="0"/>
           </a:p>
           <a:p>
-            <a:pPr indent="0" marL="0">
+            <a:pPr marL="0" indent="0">
               <a:buNone/>
             </a:pPr>
             <a:r>
@@ -6800,6 +6823,7 @@
         <a:solidFill>
           <a:srgbClr val="065A82"/>
         </a:solidFill>
+        <a:effectLst/>
       </p:bgPr>
     </p:bg>
     <p:spTree>
@@ -6840,6 +6864,13 @@
             <a:prstDash val="solid"/>
           </a:ln>
         </p:spPr>
+        <p:txBody>
+          <a:bodyPr/>
+          <a:lstStyle/>
+          <a:p>
+            <a:endParaRPr lang="it-IT"/>
+          </a:p>
+        </p:txBody>
       </p:sp>
       <p:sp>
         <p:nvSpPr>
@@ -6862,7 +6893,7 @@
           <a:bodyPr wrap="square" rtlCol="0" anchor="ctr"/>
           <a:lstStyle/>
           <a:p>
-            <a:pPr algn="ctr" indent="0" marL="0">
+            <a:pPr marL="0" indent="0" algn="ctr">
               <a:buNone/>
             </a:pPr>
             <a:r>
@@ -6904,6 +6935,13 @@
             <a:prstDash val="solid"/>
           </a:ln>
         </p:spPr>
+        <p:txBody>
+          <a:bodyPr/>
+          <a:lstStyle/>
+          <a:p>
+            <a:endParaRPr lang="it-IT"/>
+          </a:p>
+        </p:txBody>
       </p:sp>
       <p:sp>
         <p:nvSpPr>
@@ -6926,7 +6964,7 @@
           <a:bodyPr wrap="square" rtlCol="0" anchor="ctr"/>
           <a:lstStyle/>
           <a:p>
-            <a:pPr algn="ctr" indent="0" marL="0">
+            <a:pPr marL="0" indent="0" algn="ctr">
               <a:buNone/>
             </a:pPr>
             <a:r>
@@ -6960,6 +6998,7 @@
         <a:solidFill>
           <a:srgbClr val="FFFFFF"/>
         </a:solidFill>
+        <a:effectLst/>
       </p:bgPr>
     </p:bg>
     <p:spTree>
@@ -7000,6 +7039,13 @@
             <a:prstDash val="solid"/>
           </a:ln>
         </p:spPr>
+        <p:txBody>
+          <a:bodyPr/>
+          <a:lstStyle/>
+          <a:p>
+            <a:endParaRPr lang="it-IT"/>
+          </a:p>
+        </p:txBody>
       </p:sp>
       <p:sp>
         <p:nvSpPr>
@@ -7022,7 +7068,7 @@
           <a:bodyPr wrap="square" rtlCol="0" anchor="ctr"/>
           <a:lstStyle/>
           <a:p>
-            <a:pPr indent="0" marL="0">
+            <a:pPr marL="0" indent="0">
               <a:buNone/>
             </a:pPr>
             <a:r>
@@ -7049,7 +7095,7 @@
         <p:spPr>
           <a:xfrm>
             <a:off x="457200" y="914400"/>
-            <a:ext cx="5394960" cy="5303520"/>
+            <a:ext cx="5394960" cy="2732690"/>
           </a:xfrm>
           <a:prstGeom prst="rect">
             <a:avLst/>
@@ -7064,6 +7110,13 @@
             <a:prstDash val="solid"/>
           </a:ln>
         </p:spPr>
+        <p:txBody>
+          <a:bodyPr/>
+          <a:lstStyle/>
+          <a:p>
+            <a:endParaRPr lang="it-IT"/>
+          </a:p>
+        </p:txBody>
       </p:sp>
       <p:sp>
         <p:nvSpPr>
@@ -7089,6 +7142,13 @@
             <a:prstDash val="solid"/>
           </a:ln>
         </p:spPr>
+        <p:txBody>
+          <a:bodyPr/>
+          <a:lstStyle/>
+          <a:p>
+            <a:endParaRPr lang="it-IT"/>
+          </a:p>
+        </p:txBody>
       </p:sp>
       <p:sp>
         <p:nvSpPr>
@@ -7111,7 +7171,7 @@
           <a:bodyPr wrap="square" rtlCol="0" anchor="ctr"/>
           <a:lstStyle/>
           <a:p>
-            <a:pPr algn="ctr" indent="0" marL="0">
+            <a:pPr marL="0" indent="0" algn="ctr">
               <a:buNone/>
             </a:pPr>
             <a:r>
@@ -7150,7 +7210,7 @@
           <a:bodyPr wrap="square" rtlCol="0" anchor="ctr"/>
           <a:lstStyle/>
           <a:p>
-            <a:pPr algn="ctr" indent="0" marL="0">
+            <a:pPr marL="0" indent="0" algn="ctr">
               <a:buNone/>
             </a:pPr>
             <a:r>
@@ -7189,7 +7249,7 @@
           <a:bodyPr wrap="square" rtlCol="0" anchor="ctr"/>
           <a:lstStyle/>
           <a:p>
-            <a:pPr algn="ctr" indent="0" marL="0">
+            <a:pPr marL="0" indent="0" algn="ctr">
               <a:buNone/>
             </a:pPr>
             <a:r>
@@ -7228,7 +7288,7 @@
           <a:bodyPr wrap="square" rtlCol="0" anchor="ctr"/>
           <a:lstStyle/>
           <a:p>
-            <a:pPr algn="ctr" indent="0" marL="0">
+            <a:pPr marL="0" indent="0" algn="ctr">
               <a:buNone/>
             </a:pPr>
             <a:r>
@@ -7267,7 +7327,7 @@
           <a:bodyPr wrap="square" rtlCol="0" anchor="ctr"/>
           <a:lstStyle/>
           <a:p>
-            <a:pPr algn="ctr" indent="0" marL="0">
+            <a:pPr marL="0" indent="0" algn="ctr">
               <a:buNone/>
             </a:pPr>
             <a:r>
@@ -7306,11 +7366,11 @@
           <a:bodyPr wrap="square" rtlCol="0" anchor="ctr"/>
           <a:lstStyle/>
           <a:p>
-            <a:pPr algn="ctr" indent="0" marL="0">
+            <a:pPr marL="0" indent="0" algn="ctr">
               <a:buNone/>
             </a:pPr>
             <a:r>
-              <a:rPr lang="en-US" sz="2800" b="1" dirty="0">
+              <a:rPr lang="en-US" b="1" dirty="0">
                 <a:solidFill>
                   <a:srgbClr val="F39C12"/>
                 </a:solidFill>
@@ -7320,7 +7380,7 @@
               </a:rPr>
               <a:t>2020–2023</a:t>
             </a:r>
-            <a:endParaRPr lang="en-US" sz="2800" dirty="0"/>
+            <a:endParaRPr lang="en-US" dirty="0"/>
           </a:p>
         </p:txBody>
       </p:sp>
@@ -7345,7 +7405,7 @@
           <a:bodyPr wrap="square" rtlCol="0" anchor="ctr"/>
           <a:lstStyle/>
           <a:p>
-            <a:pPr algn="ctr" indent="0" marL="0">
+            <a:pPr marL="0" indent="0" algn="ctr">
               <a:buNone/>
             </a:pPr>
             <a:r>
@@ -7387,6 +7447,13 @@
             <a:prstDash val="solid"/>
           </a:ln>
         </p:spPr>
+        <p:txBody>
+          <a:bodyPr/>
+          <a:lstStyle/>
+          <a:p>
+            <a:endParaRPr lang="it-IT"/>
+          </a:p>
+        </p:txBody>
       </p:sp>
       <p:sp>
         <p:nvSpPr>
@@ -7491,7 +7558,7 @@
         <p:spPr>
           <a:xfrm>
             <a:off x="6035040" y="914400"/>
-            <a:ext cx="5394960" cy="5303520"/>
+            <a:ext cx="5394960" cy="2732690"/>
           </a:xfrm>
           <a:prstGeom prst="rect">
             <a:avLst/>
@@ -7506,6 +7573,13 @@
             <a:prstDash val="solid"/>
           </a:ln>
         </p:spPr>
+        <p:txBody>
+          <a:bodyPr/>
+          <a:lstStyle/>
+          <a:p>
+            <a:endParaRPr lang="it-IT"/>
+          </a:p>
+        </p:txBody>
       </p:sp>
       <p:sp>
         <p:nvSpPr>
@@ -7531,6 +7605,13 @@
             <a:prstDash val="solid"/>
           </a:ln>
         </p:spPr>
+        <p:txBody>
+          <a:bodyPr/>
+          <a:lstStyle/>
+          <a:p>
+            <a:endParaRPr lang="it-IT"/>
+          </a:p>
+        </p:txBody>
       </p:sp>
       <p:sp>
         <p:nvSpPr>
@@ -7553,7 +7634,7 @@
           <a:bodyPr wrap="square" rtlCol="0" anchor="ctr"/>
           <a:lstStyle/>
           <a:p>
-            <a:pPr algn="ctr" indent="0" marL="0">
+            <a:pPr marL="0" indent="0" algn="ctr">
               <a:buNone/>
             </a:pPr>
             <a:r>
@@ -7592,7 +7673,7 @@
           <a:bodyPr wrap="square" rtlCol="0" anchor="ctr"/>
           <a:lstStyle/>
           <a:p>
-            <a:pPr algn="ctr" indent="0" marL="0">
+            <a:pPr marL="0" indent="0" algn="ctr">
               <a:buNone/>
             </a:pPr>
             <a:r>
@@ -7631,7 +7712,7 @@
           <a:bodyPr wrap="square" rtlCol="0" anchor="ctr"/>
           <a:lstStyle/>
           <a:p>
-            <a:pPr algn="ctr" indent="0" marL="0">
+            <a:pPr marL="0" indent="0" algn="ctr">
               <a:buNone/>
             </a:pPr>
             <a:r>
@@ -7670,7 +7751,7 @@
           <a:bodyPr wrap="square" rtlCol="0" anchor="ctr"/>
           <a:lstStyle/>
           <a:p>
-            <a:pPr algn="ctr" indent="0" marL="0">
+            <a:pPr marL="0" indent="0" algn="ctr">
               <a:buNone/>
             </a:pPr>
             <a:r>
@@ -7709,7 +7790,7 @@
           <a:bodyPr wrap="square" rtlCol="0" anchor="ctr"/>
           <a:lstStyle/>
           <a:p>
-            <a:pPr algn="ctr" indent="0" marL="0">
+            <a:pPr marL="0" indent="0" algn="ctr">
               <a:buNone/>
             </a:pPr>
             <a:r>
@@ -7748,11 +7829,11 @@
           <a:bodyPr wrap="square" rtlCol="0" anchor="ctr"/>
           <a:lstStyle/>
           <a:p>
-            <a:pPr algn="ctr" indent="0" marL="0">
+            <a:pPr marL="0" indent="0" algn="ctr">
               <a:buNone/>
             </a:pPr>
             <a:r>
-              <a:rPr lang="en-US" sz="2800" b="1" dirty="0">
+              <a:rPr lang="en-US" b="1" dirty="0">
                 <a:solidFill>
                   <a:srgbClr val="F39C12"/>
                 </a:solidFill>
@@ -7762,7 +7843,7 @@
               </a:rPr>
               <a:t>2021–2023</a:t>
             </a:r>
-            <a:endParaRPr lang="en-US" sz="2800" dirty="0"/>
+            <a:endParaRPr lang="en-US" dirty="0"/>
           </a:p>
         </p:txBody>
       </p:sp>
@@ -7787,7 +7868,7 @@
           <a:bodyPr wrap="square" rtlCol="0" anchor="ctr"/>
           <a:lstStyle/>
           <a:p>
-            <a:pPr algn="ctr" indent="0" marL="0">
+            <a:pPr marL="0" indent="0" algn="ctr">
               <a:buNone/>
             </a:pPr>
             <a:r>
@@ -7829,6 +7910,13 @@
             <a:prstDash val="solid"/>
           </a:ln>
         </p:spPr>
+        <p:txBody>
+          <a:bodyPr/>
+          <a:lstStyle/>
+          <a:p>
+            <a:endParaRPr lang="it-IT"/>
+          </a:p>
+        </p:txBody>
       </p:sp>
       <p:sp>
         <p:nvSpPr>
@@ -7940,6 +8028,7 @@
         <a:solidFill>
           <a:srgbClr val="FFFFFF"/>
         </a:solidFill>
+        <a:effectLst/>
       </p:bgPr>
     </p:bg>
     <p:spTree>
@@ -7980,6 +8069,13 @@
             <a:prstDash val="solid"/>
           </a:ln>
         </p:spPr>
+        <p:txBody>
+          <a:bodyPr/>
+          <a:lstStyle/>
+          <a:p>
+            <a:endParaRPr lang="it-IT"/>
+          </a:p>
+        </p:txBody>
       </p:sp>
       <p:sp>
         <p:nvSpPr>
@@ -8002,7 +8098,7 @@
           <a:bodyPr wrap="square" rtlCol="0" anchor="ctr"/>
           <a:lstStyle/>
           <a:p>
-            <a:pPr indent="0" marL="0">
+            <a:pPr marL="0" indent="0">
               <a:buNone/>
             </a:pPr>
             <a:r>
@@ -8041,7 +8137,7 @@
           <a:bodyPr wrap="square" rtlCol="0" anchor="ctr"/>
           <a:lstStyle/>
           <a:p>
-            <a:pPr indent="0" marL="0">
+            <a:pPr marL="0" indent="0">
               <a:buNone/>
             </a:pPr>
             <a:r>
@@ -8075,17 +8171,41 @@
         </p:nvGraphicFramePr>
         <p:xfrm>
           <a:off x="457200" y="1188720"/>
-          <a:ext cx="11247120" cy="2560320"/>
+          <a:ext cx="11247120" cy="2377440"/>
         </p:xfrm>
         <a:graphic>
           <a:graphicData uri="http://schemas.openxmlformats.org/drawingml/2006/table">
             <a:tbl>
               <a:tblPr/>
               <a:tblGrid>
-                <a:gridCol w="2560320"/>
-                <a:gridCol w="2743200"/>
-                <a:gridCol w="2926080"/>
-                <a:gridCol w="3017520"/>
+                <a:gridCol w="2560320">
+                  <a:extLst>
+                    <a:ext uri="{9D8B030D-6E8A-4147-A177-3AD203B41FA5}">
+                      <a16:colId xmlns:a16="http://schemas.microsoft.com/office/drawing/2014/main" val="20000"/>
+                    </a:ext>
+                  </a:extLst>
+                </a:gridCol>
+                <a:gridCol w="2743200">
+                  <a:extLst>
+                    <a:ext uri="{9D8B030D-6E8A-4147-A177-3AD203B41FA5}">
+                      <a16:colId xmlns:a16="http://schemas.microsoft.com/office/drawing/2014/main" val="20001"/>
+                    </a:ext>
+                  </a:extLst>
+                </a:gridCol>
+                <a:gridCol w="2926080">
+                  <a:extLst>
+                    <a:ext uri="{9D8B030D-6E8A-4147-A177-3AD203B41FA5}">
+                      <a16:colId xmlns:a16="http://schemas.microsoft.com/office/drawing/2014/main" val="20002"/>
+                    </a:ext>
+                  </a:extLst>
+                </a:gridCol>
+                <a:gridCol w="3017520">
+                  <a:extLst>
+                    <a:ext uri="{9D8B030D-6E8A-4147-A177-3AD203B41FA5}">
+                      <a16:colId xmlns:a16="http://schemas.microsoft.com/office/drawing/2014/main" val="20003"/>
+                    </a:ext>
+                  </a:extLst>
+                </a:gridCol>
               </a:tblGrid>
               <a:tr h="475488">
                 <a:tc>
@@ -8093,7 +8213,7 @@
                     <a:bodyPr/>
                     <a:lstStyle/>
                     <a:p>
-                      <a:pPr indent="0" marL="0">
+                      <a:pPr marL="0" indent="0">
                         <a:buNone/>
                       </a:pPr>
                       <a:r>
@@ -8114,7 +8234,7 @@
                       </a:endParaRPr>
                     </a:p>
                   </a:txBody>
-                  <a:tcPr marL="91440" marR="91440" marT="45720" marB="45720">
+                  <a:tcPr>
                     <a:lnL w="12700" cap="flat" cmpd="sng" algn="ctr">
                       <a:solidFill>
                         <a:srgbClr val="C8DCE8"/>
@@ -8161,7 +8281,7 @@
                     <a:bodyPr/>
                     <a:lstStyle/>
                     <a:p>
-                      <a:pPr indent="0" marL="0">
+                      <a:pPr marL="0" indent="0">
                         <a:buNone/>
                       </a:pPr>
                       <a:r>
@@ -8182,7 +8302,7 @@
                       </a:endParaRPr>
                     </a:p>
                   </a:txBody>
-                  <a:tcPr marL="91440" marR="91440" marT="45720" marB="45720">
+                  <a:tcPr>
                     <a:lnL w="12700" cap="flat" cmpd="sng" algn="ctr">
                       <a:solidFill>
                         <a:srgbClr val="C8DCE8"/>
@@ -8229,7 +8349,7 @@
                     <a:bodyPr/>
                     <a:lstStyle/>
                     <a:p>
-                      <a:pPr indent="0" marL="0">
+                      <a:pPr marL="0" indent="0">
                         <a:buNone/>
                       </a:pPr>
                       <a:r>
@@ -8250,7 +8370,7 @@
                       </a:endParaRPr>
                     </a:p>
                   </a:txBody>
-                  <a:tcPr marL="91440" marR="91440" marT="45720" marB="45720">
+                  <a:tcPr>
                     <a:lnL w="12700" cap="flat" cmpd="sng" algn="ctr">
                       <a:solidFill>
                         <a:srgbClr val="C8DCE8"/>
@@ -8297,7 +8417,7 @@
                     <a:bodyPr/>
                     <a:lstStyle/>
                     <a:p>
-                      <a:pPr indent="0" marL="0">
+                      <a:pPr marL="0" indent="0">
                         <a:buNone/>
                       </a:pPr>
                       <a:r>
@@ -8318,7 +8438,7 @@
                       </a:endParaRPr>
                     </a:p>
                   </a:txBody>
-                  <a:tcPr marL="91440" marR="91440" marT="45720" marB="45720">
+                  <a:tcPr>
                     <a:lnL w="12700" cap="flat" cmpd="sng" algn="ctr">
                       <a:solidFill>
                         <a:srgbClr val="C8DCE8"/>
@@ -8360,6 +8480,11 @@
                     </a:solidFill>
                   </a:tcPr>
                 </a:tc>
+                <a:extLst>
+                  <a:ext uri="{0D108BD9-81ED-4DB2-BD59-A6C34878D82A}">
+                    <a16:rowId xmlns:a16="http://schemas.microsoft.com/office/drawing/2014/main" val="10000"/>
+                  </a:ext>
+                </a:extLst>
               </a:tr>
               <a:tr h="475488">
                 <a:tc>
@@ -8367,7 +8492,7 @@
                     <a:bodyPr/>
                     <a:lstStyle/>
                     <a:p>
-                      <a:pPr indent="0" marL="0">
+                      <a:pPr marL="0" indent="0">
                         <a:buNone/>
                       </a:pPr>
                       <a:r>
@@ -8388,7 +8513,7 @@
                       </a:endParaRPr>
                     </a:p>
                   </a:txBody>
-                  <a:tcPr marL="91440" marR="91440" marT="45720" marB="45720">
+                  <a:tcPr>
                     <a:lnL w="12700" cap="flat" cmpd="sng" algn="ctr">
                       <a:solidFill>
                         <a:srgbClr val="C8DCE8"/>
@@ -8435,7 +8560,7 @@
                     <a:bodyPr/>
                     <a:lstStyle/>
                     <a:p>
-                      <a:pPr indent="0" marL="0">
+                      <a:pPr marL="0" indent="0">
                         <a:buNone/>
                       </a:pPr>
                       <a:r>
@@ -8456,7 +8581,7 @@
                       </a:endParaRPr>
                     </a:p>
                   </a:txBody>
-                  <a:tcPr marL="91440" marR="91440" marT="45720" marB="45720">
+                  <a:tcPr>
                     <a:lnL w="12700" cap="flat" cmpd="sng" algn="ctr">
                       <a:solidFill>
                         <a:srgbClr val="C8DCE8"/>
@@ -8503,7 +8628,7 @@
                     <a:bodyPr/>
                     <a:lstStyle/>
                     <a:p>
-                      <a:pPr indent="0" marL="0">
+                      <a:pPr marL="0" indent="0">
                         <a:buNone/>
                       </a:pPr>
                       <a:r>
@@ -8524,7 +8649,7 @@
                       </a:endParaRPr>
                     </a:p>
                   </a:txBody>
-                  <a:tcPr marL="91440" marR="91440" marT="45720" marB="45720">
+                  <a:tcPr>
                     <a:lnL w="12700" cap="flat" cmpd="sng" algn="ctr">
                       <a:solidFill>
                         <a:srgbClr val="C8DCE8"/>
@@ -8571,7 +8696,7 @@
                     <a:bodyPr/>
                     <a:lstStyle/>
                     <a:p>
-                      <a:pPr indent="0" marL="0">
+                      <a:pPr marL="0" indent="0">
                         <a:buNone/>
                       </a:pPr>
                       <a:r>
@@ -8592,7 +8717,7 @@
                       </a:endParaRPr>
                     </a:p>
                   </a:txBody>
-                  <a:tcPr marL="91440" marR="91440" marT="45720" marB="45720">
+                  <a:tcPr>
                     <a:lnL w="12700" cap="flat" cmpd="sng" algn="ctr">
                       <a:solidFill>
                         <a:srgbClr val="C8DCE8"/>
@@ -8634,6 +8759,11 @@
                     </a:solidFill>
                   </a:tcPr>
                 </a:tc>
+                <a:extLst>
+                  <a:ext uri="{0D108BD9-81ED-4DB2-BD59-A6C34878D82A}">
+                    <a16:rowId xmlns:a16="http://schemas.microsoft.com/office/drawing/2014/main" val="10001"/>
+                  </a:ext>
+                </a:extLst>
               </a:tr>
               <a:tr h="475488">
                 <a:tc>
@@ -8641,7 +8771,7 @@
                     <a:bodyPr/>
                     <a:lstStyle/>
                     <a:p>
-                      <a:pPr indent="0" marL="0">
+                      <a:pPr marL="0" indent="0">
                         <a:buNone/>
                       </a:pPr>
                       <a:r>
@@ -8662,7 +8792,7 @@
                       </a:endParaRPr>
                     </a:p>
                   </a:txBody>
-                  <a:tcPr marL="91440" marR="91440" marT="45720" marB="45720">
+                  <a:tcPr>
                     <a:lnL w="12700" cap="flat" cmpd="sng" algn="ctr">
                       <a:solidFill>
                         <a:srgbClr val="C8DCE8"/>
@@ -8709,7 +8839,7 @@
                     <a:bodyPr/>
                     <a:lstStyle/>
                     <a:p>
-                      <a:pPr indent="0" marL="0">
+                      <a:pPr marL="0" indent="0">
                         <a:buNone/>
                       </a:pPr>
                       <a:r>
@@ -8730,7 +8860,7 @@
                       </a:endParaRPr>
                     </a:p>
                   </a:txBody>
-                  <a:tcPr marL="91440" marR="91440" marT="45720" marB="45720">
+                  <a:tcPr>
                     <a:lnL w="12700" cap="flat" cmpd="sng" algn="ctr">
                       <a:solidFill>
                         <a:srgbClr val="C8DCE8"/>
@@ -8777,7 +8907,7 @@
                     <a:bodyPr/>
                     <a:lstStyle/>
                     <a:p>
-                      <a:pPr indent="0" marL="0">
+                      <a:pPr marL="0" indent="0">
                         <a:buNone/>
                       </a:pPr>
                       <a:r>
@@ -8798,7 +8928,7 @@
                       </a:endParaRPr>
                     </a:p>
                   </a:txBody>
-                  <a:tcPr marL="91440" marR="91440" marT="45720" marB="45720">
+                  <a:tcPr>
                     <a:lnL w="12700" cap="flat" cmpd="sng" algn="ctr">
                       <a:solidFill>
                         <a:srgbClr val="C8DCE8"/>
@@ -8845,7 +8975,7 @@
                     <a:bodyPr/>
                     <a:lstStyle/>
                     <a:p>
-                      <a:pPr indent="0" marL="0">
+                      <a:pPr marL="0" indent="0">
                         <a:buNone/>
                       </a:pPr>
                       <a:r>
@@ -8866,7 +8996,7 @@
                       </a:endParaRPr>
                     </a:p>
                   </a:txBody>
-                  <a:tcPr marL="91440" marR="91440" marT="45720" marB="45720">
+                  <a:tcPr>
                     <a:lnL w="12700" cap="flat" cmpd="sng" algn="ctr">
                       <a:solidFill>
                         <a:srgbClr val="C8DCE8"/>
@@ -8908,6 +9038,11 @@
                     </a:solidFill>
                   </a:tcPr>
                 </a:tc>
+                <a:extLst>
+                  <a:ext uri="{0D108BD9-81ED-4DB2-BD59-A6C34878D82A}">
+                    <a16:rowId xmlns:a16="http://schemas.microsoft.com/office/drawing/2014/main" val="10002"/>
+                  </a:ext>
+                </a:extLst>
               </a:tr>
               <a:tr h="475488">
                 <a:tc>
@@ -8915,7 +9050,7 @@
                     <a:bodyPr/>
                     <a:lstStyle/>
                     <a:p>
-                      <a:pPr indent="0" marL="0">
+                      <a:pPr marL="0" indent="0">
                         <a:buNone/>
                       </a:pPr>
                       <a:r>
@@ -8936,7 +9071,7 @@
                       </a:endParaRPr>
                     </a:p>
                   </a:txBody>
-                  <a:tcPr marL="91440" marR="91440" marT="45720" marB="45720">
+                  <a:tcPr>
                     <a:lnL w="12700" cap="flat" cmpd="sng" algn="ctr">
                       <a:solidFill>
                         <a:srgbClr val="C8DCE8"/>
@@ -8983,7 +9118,7 @@
                     <a:bodyPr/>
                     <a:lstStyle/>
                     <a:p>
-                      <a:pPr indent="0" marL="0">
+                      <a:pPr marL="0" indent="0">
                         <a:buNone/>
                       </a:pPr>
                       <a:r>
@@ -9004,7 +9139,7 @@
                       </a:endParaRPr>
                     </a:p>
                   </a:txBody>
-                  <a:tcPr marL="91440" marR="91440" marT="45720" marB="45720">
+                  <a:tcPr>
                     <a:lnL w="12700" cap="flat" cmpd="sng" algn="ctr">
                       <a:solidFill>
                         <a:srgbClr val="C8DCE8"/>
@@ -9051,7 +9186,7 @@
                     <a:bodyPr/>
                     <a:lstStyle/>
                     <a:p>
-                      <a:pPr indent="0" marL="0">
+                      <a:pPr marL="0" indent="0">
                         <a:buNone/>
                       </a:pPr>
                       <a:r>
@@ -9072,7 +9207,7 @@
                       </a:endParaRPr>
                     </a:p>
                   </a:txBody>
-                  <a:tcPr marL="91440" marR="91440" marT="45720" marB="45720">
+                  <a:tcPr>
                     <a:lnL w="12700" cap="flat" cmpd="sng" algn="ctr">
                       <a:solidFill>
                         <a:srgbClr val="C8DCE8"/>
@@ -9119,7 +9254,7 @@
                     <a:bodyPr/>
                     <a:lstStyle/>
                     <a:p>
-                      <a:pPr indent="0" marL="0">
+                      <a:pPr marL="0" indent="0">
                         <a:buNone/>
                       </a:pPr>
                       <a:r>
@@ -9140,7 +9275,7 @@
                       </a:endParaRPr>
                     </a:p>
                   </a:txBody>
-                  <a:tcPr marL="91440" marR="91440" marT="45720" marB="45720">
+                  <a:tcPr>
                     <a:lnL w="12700" cap="flat" cmpd="sng" algn="ctr">
                       <a:solidFill>
                         <a:srgbClr val="C8DCE8"/>
@@ -9182,6 +9317,11 @@
                     </a:solidFill>
                   </a:tcPr>
                 </a:tc>
+                <a:extLst>
+                  <a:ext uri="{0D108BD9-81ED-4DB2-BD59-A6C34878D82A}">
+                    <a16:rowId xmlns:a16="http://schemas.microsoft.com/office/drawing/2014/main" val="10003"/>
+                  </a:ext>
+                </a:extLst>
               </a:tr>
               <a:tr h="475488">
                 <a:tc>
@@ -9189,7 +9329,7 @@
                     <a:bodyPr/>
                     <a:lstStyle/>
                     <a:p>
-                      <a:pPr indent="0" marL="0">
+                      <a:pPr marL="0" indent="0">
                         <a:buNone/>
                       </a:pPr>
                       <a:r>
@@ -9210,7 +9350,7 @@
                       </a:endParaRPr>
                     </a:p>
                   </a:txBody>
-                  <a:tcPr marL="91440" marR="91440" marT="45720" marB="45720">
+                  <a:tcPr>
                     <a:lnL w="12700" cap="flat" cmpd="sng" algn="ctr">
                       <a:solidFill>
                         <a:srgbClr val="C8DCE8"/>
@@ -9257,7 +9397,7 @@
                     <a:bodyPr/>
                     <a:lstStyle/>
                     <a:p>
-                      <a:pPr indent="0" marL="0">
+                      <a:pPr marL="0" indent="0">
                         <a:buNone/>
                       </a:pPr>
                       <a:r>
@@ -9278,7 +9418,7 @@
                       </a:endParaRPr>
                     </a:p>
                   </a:txBody>
-                  <a:tcPr marL="91440" marR="91440" marT="45720" marB="45720">
+                  <a:tcPr>
                     <a:lnL w="12700" cap="flat" cmpd="sng" algn="ctr">
                       <a:solidFill>
                         <a:srgbClr val="C8DCE8"/>
@@ -9325,7 +9465,7 @@
                     <a:bodyPr/>
                     <a:lstStyle/>
                     <a:p>
-                      <a:pPr indent="0" marL="0">
+                      <a:pPr marL="0" indent="0">
                         <a:buNone/>
                       </a:pPr>
                       <a:r>
@@ -9346,7 +9486,7 @@
                       </a:endParaRPr>
                     </a:p>
                   </a:txBody>
-                  <a:tcPr marL="91440" marR="91440" marT="45720" marB="45720">
+                  <a:tcPr>
                     <a:lnL w="12700" cap="flat" cmpd="sng" algn="ctr">
                       <a:solidFill>
                         <a:srgbClr val="C8DCE8"/>
@@ -9393,7 +9533,7 @@
                     <a:bodyPr/>
                     <a:lstStyle/>
                     <a:p>
-                      <a:pPr indent="0" marL="0">
+                      <a:pPr marL="0" indent="0">
                         <a:buNone/>
                       </a:pPr>
                       <a:r>
@@ -9414,7 +9554,7 @@
                       </a:endParaRPr>
                     </a:p>
                   </a:txBody>
-                  <a:tcPr marL="91440" marR="91440" marT="45720" marB="45720">
+                  <a:tcPr>
                     <a:lnL w="12700" cap="flat" cmpd="sng" algn="ctr">
                       <a:solidFill>
                         <a:srgbClr val="C8DCE8"/>
@@ -9456,6 +9596,11 @@
                     </a:solidFill>
                   </a:tcPr>
                 </a:tc>
+                <a:extLst>
+                  <a:ext uri="{0D108BD9-81ED-4DB2-BD59-A6C34878D82A}">
+                    <a16:rowId xmlns:a16="http://schemas.microsoft.com/office/drawing/2014/main" val="10004"/>
+                  </a:ext>
+                </a:extLst>
               </a:tr>
             </a:tbl>
           </a:graphicData>
@@ -9463,7 +9608,7 @@
       </p:graphicFrame>
       <p:sp>
         <p:nvSpPr>
-          <p:cNvPr id="6" name="Shape 3"/>
+          <p:cNvPr id="5" name="Shape 3"/>
           <p:cNvSpPr/>
           <p:nvPr/>
         </p:nvSpPr>
@@ -9485,6 +9630,13 @@
             <a:prstDash val="solid"/>
           </a:ln>
         </p:spPr>
+        <p:txBody>
+          <a:bodyPr/>
+          <a:lstStyle/>
+          <a:p>
+            <a:endParaRPr lang="it-IT"/>
+          </a:p>
+        </p:txBody>
       </p:sp>
       <p:sp>
         <p:nvSpPr>
@@ -9507,7 +9659,7 @@
           <a:bodyPr wrap="square" rtlCol="0" anchor="ctr"/>
           <a:lstStyle/>
           <a:p>
-            <a:pPr indent="0" marL="0">
+            <a:pPr marL="0" indent="0">
               <a:buNone/>
             </a:pPr>
             <a:r>
@@ -9524,7 +9676,7 @@
             <a:endParaRPr lang="en-US" sz="1300" dirty="0"/>
           </a:p>
           <a:p>
-            <a:pPr indent="0" marL="0">
+            <a:pPr marL="0" indent="0">
               <a:buNone/>
             </a:pPr>
             <a:r>
@@ -9566,6 +9718,13 @@
             <a:prstDash val="solid"/>
           </a:ln>
         </p:spPr>
+        <p:txBody>
+          <a:bodyPr/>
+          <a:lstStyle/>
+          <a:p>
+            <a:endParaRPr lang="it-IT"/>
+          </a:p>
+        </p:txBody>
       </p:sp>
       <p:sp>
         <p:nvSpPr>
@@ -9588,7 +9747,7 @@
           <a:bodyPr wrap="square" rtlCol="0" anchor="ctr"/>
           <a:lstStyle/>
           <a:p>
-            <a:pPr algn="ctr" indent="0" marL="0">
+            <a:pPr marL="0" indent="0" algn="ctr">
               <a:buNone/>
             </a:pPr>
             <a:r>
@@ -9630,6 +9789,13 @@
             <a:prstDash val="solid"/>
           </a:ln>
         </p:spPr>
+        <p:txBody>
+          <a:bodyPr/>
+          <a:lstStyle/>
+          <a:p>
+            <a:endParaRPr lang="it-IT"/>
+          </a:p>
+        </p:txBody>
       </p:sp>
       <p:sp>
         <p:nvSpPr>
@@ -9652,20 +9818,9 @@
           <a:bodyPr wrap="square" rtlCol="0" anchor="ctr"/>
           <a:lstStyle/>
           <a:p>
-            <a:pPr algn="ctr" indent="0" marL="0">
+            <a:pPr marL="0" indent="0" algn="ctr">
               <a:buNone/>
             </a:pPr>
-            <a:r>
-              <a:rPr lang="en-US" sz="1200" dirty="0">
-                <a:solidFill>
-                  <a:srgbClr val="333333"/>
-                </a:solidFill>
-                <a:latin typeface="Calibri" pitchFamily="34" charset="0"/>
-                <a:ea typeface="Calibri" pitchFamily="34" charset="-122"/>
-                <a:cs typeface="Calibri" pitchFamily="34" charset="-120"/>
-              </a:rPr>
-              <a:t>▶</a:t>
-            </a:r>
             <a:endParaRPr lang="en-US" sz="1200" dirty="0"/>
           </a:p>
         </p:txBody>
@@ -9694,6 +9849,13 @@
             <a:prstDash val="solid"/>
           </a:ln>
         </p:spPr>
+        <p:txBody>
+          <a:bodyPr/>
+          <a:lstStyle/>
+          <a:p>
+            <a:endParaRPr lang="it-IT"/>
+          </a:p>
+        </p:txBody>
       </p:sp>
       <p:sp>
         <p:nvSpPr>
@@ -9716,7 +9878,7 @@
           <a:bodyPr wrap="square" rtlCol="0" anchor="ctr"/>
           <a:lstStyle/>
           <a:p>
-            <a:pPr algn="ctr" indent="0" marL="0">
+            <a:pPr marL="0" indent="0" algn="ctr">
               <a:buNone/>
             </a:pPr>
             <a:r>
@@ -9758,6 +9920,13 @@
             <a:prstDash val="solid"/>
           </a:ln>
         </p:spPr>
+        <p:txBody>
+          <a:bodyPr/>
+          <a:lstStyle/>
+          <a:p>
+            <a:endParaRPr lang="it-IT"/>
+          </a:p>
+        </p:txBody>
       </p:sp>
       <p:sp>
         <p:nvSpPr>
@@ -9780,20 +9949,9 @@
           <a:bodyPr wrap="square" rtlCol="0" anchor="ctr"/>
           <a:lstStyle/>
           <a:p>
-            <a:pPr algn="ctr" indent="0" marL="0">
+            <a:pPr marL="0" indent="0" algn="ctr">
               <a:buNone/>
             </a:pPr>
-            <a:r>
-              <a:rPr lang="en-US" sz="1200" dirty="0">
-                <a:solidFill>
-                  <a:srgbClr val="333333"/>
-                </a:solidFill>
-                <a:latin typeface="Calibri" pitchFamily="34" charset="0"/>
-                <a:ea typeface="Calibri" pitchFamily="34" charset="-122"/>
-                <a:cs typeface="Calibri" pitchFamily="34" charset="-120"/>
-              </a:rPr>
-              <a:t>▶</a:t>
-            </a:r>
             <a:endParaRPr lang="en-US" sz="1200" dirty="0"/>
           </a:p>
         </p:txBody>
@@ -9822,6 +9980,13 @@
             <a:prstDash val="solid"/>
           </a:ln>
         </p:spPr>
+        <p:txBody>
+          <a:bodyPr/>
+          <a:lstStyle/>
+          <a:p>
+            <a:endParaRPr lang="it-IT"/>
+          </a:p>
+        </p:txBody>
       </p:sp>
       <p:sp>
         <p:nvSpPr>
@@ -9844,7 +10009,7 @@
           <a:bodyPr wrap="square" rtlCol="0" anchor="ctr"/>
           <a:lstStyle/>
           <a:p>
-            <a:pPr algn="ctr" indent="0" marL="0">
+            <a:pPr marL="0" indent="0" algn="ctr">
               <a:buNone/>
             </a:pPr>
             <a:r>
@@ -9878,6 +10043,7 @@
         <a:solidFill>
           <a:srgbClr val="065A82"/>
         </a:solidFill>
+        <a:effectLst/>
       </p:bgPr>
     </p:bg>
     <p:spTree>
@@ -9920,7 +10086,10 @@
         </p:spPr>
         <p:txBody>
           <a:bodyPr/>
-          <a:p/>
+          <a:lstStyle/>
+          <a:p>
+            <a:endParaRPr/>
+          </a:p>
         </p:txBody>
       </p:sp>
       <p:sp>
@@ -9944,7 +10113,7 @@
           <a:bodyPr wrap="square" rtlCol="0" anchor="ctr"/>
           <a:lstStyle/>
           <a:p>
-            <a:pPr algn="ctr" indent="0" marL="0">
+            <a:pPr marL="0" indent="0" algn="ctr">
               <a:buNone/>
             </a:pPr>
             <a:r>
@@ -9988,7 +10157,10 @@
         </p:spPr>
         <p:txBody>
           <a:bodyPr/>
-          <a:p/>
+          <a:lstStyle/>
+          <a:p>
+            <a:endParaRPr/>
+          </a:p>
         </p:txBody>
       </p:sp>
       <p:sp>
@@ -10012,7 +10184,7 @@
           <a:bodyPr wrap="square" rtlCol="0" anchor="ctr"/>
           <a:lstStyle/>
           <a:p>
-            <a:pPr algn="ctr" indent="0" marL="0">
+            <a:pPr marL="0" indent="0" algn="ctr">
               <a:buNone/>
             </a:pPr>
             <a:r>
@@ -10046,6 +10218,7 @@
         <a:solidFill>
           <a:srgbClr val="FFFFFF"/>
         </a:solidFill>
+        <a:effectLst/>
       </p:bgPr>
     </p:bg>
     <p:spTree>
@@ -10086,6 +10259,13 @@
             <a:prstDash val="solid"/>
           </a:ln>
         </p:spPr>
+        <p:txBody>
+          <a:bodyPr/>
+          <a:lstStyle/>
+          <a:p>
+            <a:endParaRPr lang="it-IT"/>
+          </a:p>
+        </p:txBody>
       </p:sp>
       <p:sp>
         <p:nvSpPr>
@@ -10108,7 +10288,7 @@
           <a:bodyPr wrap="square" rtlCol="0" anchor="ctr"/>
           <a:lstStyle/>
           <a:p>
-            <a:pPr indent="0" marL="0">
+            <a:pPr marL="0" indent="0">
               <a:buNone/>
             </a:pPr>
             <a:r>
@@ -10128,14 +10308,14 @@
       </p:sp>
       <p:pic>
         <p:nvPicPr>
-          <p:cNvPr id="4" name="Image 0" descr="/Users/danieleuras/Documents/GitHub/hhe-labsardinia/data/figures/beach_trend_per_station.png">    </p:cNvPr>
+          <p:cNvPr id="4" name="Image 0" descr="/Users/danieleuras/Documents/GitHub/hhe-labsardinia/data/figures/beach_trend_per_station.png"/>
           <p:cNvPicPr>
             <a:picLocks noChangeAspect="1"/>
           </p:cNvPicPr>
           <p:nvPr/>
         </p:nvPicPr>
         <p:blipFill>
-          <a:blip r:embed="rId1"/>
+          <a:blip r:embed="rId3"/>
           <a:stretch>
             <a:fillRect/>
           </a:stretch>
@@ -10174,6 +10354,13 @@
             <a:prstDash val="solid"/>
           </a:ln>
         </p:spPr>
+        <p:txBody>
+          <a:bodyPr/>
+          <a:lstStyle/>
+          <a:p>
+            <a:endParaRPr lang="it-IT"/>
+          </a:p>
+        </p:txBody>
       </p:sp>
       <p:sp>
         <p:nvSpPr>
@@ -10196,7 +10383,7 @@
           <a:bodyPr wrap="square" rtlCol="0" anchor="ctr"/>
           <a:lstStyle/>
           <a:p>
-            <a:pPr indent="0" marL="0">
+            <a:pPr marL="0" indent="0">
               <a:buNone/>
             </a:pPr>
             <a:r>
@@ -10235,7 +10422,7 @@
           <a:bodyPr wrap="square" rtlCol="0" anchor="ctr"/>
           <a:lstStyle/>
           <a:p>
-            <a:pPr indent="0" marL="0">
+            <a:pPr marL="0" indent="0">
               <a:buNone/>
             </a:pPr>
             <a:r>
@@ -10274,7 +10461,7 @@
           <a:bodyPr wrap="square" rtlCol="0" anchor="ctr"/>
           <a:lstStyle/>
           <a:p>
-            <a:pPr indent="0" marL="0">
+            <a:pPr marL="0" indent="0">
               <a:buNone/>
             </a:pPr>
             <a:r>
@@ -10313,7 +10500,7 @@
           <a:bodyPr wrap="square" rtlCol="0" anchor="ctr"/>
           <a:lstStyle/>
           <a:p>
-            <a:pPr indent="0" marL="0">
+            <a:pPr marL="0" indent="0">
               <a:buNone/>
             </a:pPr>
             <a:r>
@@ -10352,7 +10539,7 @@
           <a:bodyPr wrap="square" rtlCol="0" anchor="ctr"/>
           <a:lstStyle/>
           <a:p>
-            <a:pPr indent="0" marL="0">
+            <a:pPr marL="0" indent="0">
               <a:buNone/>
             </a:pPr>
             <a:r>
@@ -10391,7 +10578,7 @@
           <a:bodyPr wrap="square" rtlCol="0" anchor="ctr"/>
           <a:lstStyle/>
           <a:p>
-            <a:pPr indent="0" marL="0">
+            <a:pPr marL="0" indent="0">
               <a:buNone/>
             </a:pPr>
             <a:r>
@@ -10430,7 +10617,7 @@
           <a:bodyPr wrap="square" rtlCol="0" anchor="ctr"/>
           <a:lstStyle/>
           <a:p>
-            <a:pPr indent="0" marL="0">
+            <a:pPr marL="0" indent="0">
               <a:buNone/>
             </a:pPr>
             <a:r>
@@ -10472,6 +10659,13 @@
             <a:prstDash val="solid"/>
           </a:ln>
         </p:spPr>
+        <p:txBody>
+          <a:bodyPr/>
+          <a:lstStyle/>
+          <a:p>
+            <a:endParaRPr lang="it-IT"/>
+          </a:p>
+        </p:txBody>
       </p:sp>
       <p:sp>
         <p:nvSpPr>
@@ -10494,7 +10688,7 @@
           <a:bodyPr wrap="square" rtlCol="0" anchor="ctr"/>
           <a:lstStyle/>
           <a:p>
-            <a:pPr algn="ctr" indent="0" marL="0">
+            <a:pPr marL="0" indent="0" algn="ctr">
               <a:buNone/>
             </a:pPr>
             <a:r>
@@ -10528,6 +10722,7 @@
         <a:solidFill>
           <a:srgbClr val="FFFFFF"/>
         </a:solidFill>
+        <a:effectLst/>
       </p:bgPr>
     </p:bg>
     <p:spTree>
@@ -10568,6 +10763,13 @@
             <a:prstDash val="solid"/>
           </a:ln>
         </p:spPr>
+        <p:txBody>
+          <a:bodyPr/>
+          <a:lstStyle/>
+          <a:p>
+            <a:endParaRPr lang="it-IT"/>
+          </a:p>
+        </p:txBody>
       </p:sp>
       <p:sp>
         <p:nvSpPr>
@@ -10590,7 +10792,7 @@
           <a:bodyPr wrap="square" rtlCol="0" anchor="ctr"/>
           <a:lstStyle/>
           <a:p>
-            <a:pPr indent="0" marL="0">
+            <a:pPr marL="0" indent="0">
               <a:buNone/>
             </a:pPr>
             <a:r>
@@ -10610,14 +10812,14 @@
       </p:sp>
       <p:pic>
         <p:nvPicPr>
-          <p:cNvPr id="4" name="Image 0" descr="/Users/danieleuras/Documents/GitHub/hhe-labsardinia/data/figures/beach_top_categories.png">    </p:cNvPr>
+          <p:cNvPr id="4" name="Image 0" descr="/Users/danieleuras/Documents/GitHub/hhe-labsardinia/data/figures/beach_top_categories.png"/>
           <p:cNvPicPr>
             <a:picLocks noChangeAspect="1"/>
           </p:cNvPicPr>
           <p:nvPr/>
         </p:nvPicPr>
         <p:blipFill>
-          <a:blip r:embed="rId1"/>
+          <a:blip r:embed="rId3"/>
           <a:stretch>
             <a:fillRect/>
           </a:stretch>
@@ -10653,7 +10855,7 @@
           <a:bodyPr wrap="square" rtlCol="0" anchor="ctr"/>
           <a:lstStyle/>
           <a:p>
-            <a:pPr algn="ctr" indent="0" marL="0">
+            <a:pPr marL="0" indent="0" algn="ctr">
               <a:buNone/>
             </a:pPr>
             <a:r>
@@ -10673,14 +10875,14 @@
       </p:sp>
       <p:pic>
         <p:nvPicPr>
-          <p:cNvPr id="6" name="Image 1" descr="/Users/danieleuras/Documents/GitHub/hhe-labsardinia/data/figures/beach_source_attribution.png">    </p:cNvPr>
+          <p:cNvPr id="6" name="Image 1" descr="/Users/danieleuras/Documents/GitHub/hhe-labsardinia/data/figures/beach_source_attribution.png"/>
           <p:cNvPicPr>
             <a:picLocks noChangeAspect="1"/>
           </p:cNvPicPr>
           <p:nvPr/>
         </p:nvPicPr>
         <p:blipFill>
-          <a:blip r:embed="rId2"/>
+          <a:blip r:embed="rId4"/>
           <a:stretch>
             <a:fillRect/>
           </a:stretch>
@@ -10716,7 +10918,7 @@
           <a:bodyPr wrap="square" rtlCol="0" anchor="ctr"/>
           <a:lstStyle/>
           <a:p>
-            <a:pPr algn="ctr" indent="0" marL="0">
+            <a:pPr marL="0" indent="0" algn="ctr">
               <a:buNone/>
             </a:pPr>
             <a:r>
@@ -10750,6 +10952,7 @@
         <a:solidFill>
           <a:srgbClr val="FFFFFF"/>
         </a:solidFill>
+        <a:effectLst/>
       </p:bgPr>
     </p:bg>
     <p:spTree>
@@ -10792,7 +10995,10 @@
         </p:spPr>
         <p:txBody>
           <a:bodyPr/>
-          <a:p/>
+          <a:lstStyle/>
+          <a:p>
+            <a:endParaRPr/>
+          </a:p>
         </p:txBody>
       </p:sp>
       <p:sp>
@@ -10816,7 +11022,7 @@
           <a:bodyPr wrap="square" rtlCol="0" anchor="ctr"/>
           <a:lstStyle/>
           <a:p>
-            <a:pPr indent="0" marL="0">
+            <a:pPr marL="0" indent="0">
               <a:buNone/>
             </a:pPr>
             <a:r>
@@ -10836,14 +11042,14 @@
       </p:sp>
       <p:pic>
         <p:nvPicPr>
-          <p:cNvPr id="4" name="Image 0" descr="/Users/danieleuras/Documents/GitHub/hhe-labsardinia/data/figures/floating_material_pie.png">    </p:cNvPr>
+          <p:cNvPr id="4" name="Image 0" descr="/Users/danieleuras/Documents/GitHub/hhe-labsardinia/data/figures/floating_material_pie.png"/>
           <p:cNvPicPr>
             <a:picLocks noChangeAspect="1"/>
           </p:cNvPicPr>
           <p:nvPr/>
         </p:nvPicPr>
         <p:blipFill>
-          <a:blip r:embed="rId1"/>
+          <a:blip r:embed="rId3"/>
           <a:stretch>
             <a:fillRect/>
           </a:stretch>
@@ -10860,14 +11066,14 @@
       </p:pic>
       <p:pic>
         <p:nvPicPr>
-          <p:cNvPr id="5" name="Image 1" descr="/Users/danieleuras/Documents/GitHub/hhe-labsardinia/data/figures/floating_seasonality.png">    </p:cNvPr>
+          <p:cNvPr id="5" name="Image 1" descr="/Users/danieleuras/Documents/GitHub/hhe-labsardinia/data/figures/floating_seasonality.png"/>
           <p:cNvPicPr>
             <a:picLocks noChangeAspect="1"/>
           </p:cNvPicPr>
           <p:nvPr/>
         </p:nvPicPr>
         <p:blipFill>
-          <a:blip r:embed="rId2"/>
+          <a:blip r:embed="rId4"/>
           <a:stretch>
             <a:fillRect/>
           </a:stretch>
@@ -10908,7 +11114,10 @@
         </p:spPr>
         <p:txBody>
           <a:bodyPr/>
-          <a:p/>
+          <a:lstStyle/>
+          <a:p>
+            <a:endParaRPr/>
+          </a:p>
         </p:txBody>
       </p:sp>
       <p:sp>
@@ -10932,7 +11141,7 @@
           <a:bodyPr wrap="square" rtlCol="0" anchor="ctr"/>
           <a:lstStyle/>
           <a:p>
-            <a:pPr algn="ctr" indent="0" marL="0">
+            <a:pPr marL="0" indent="0" algn="ctr">
               <a:buNone/>
             </a:pPr>
             <a:r>
@@ -11251,4 +11460,319 @@
     </a:ext>
   </a:extLst>
 </a:theme>
+</file>
+
+<file path=ppt/theme/theme2.xml><?xml version="1.0" encoding="utf-8"?>
+<a:theme xmlns:a="http://schemas.openxmlformats.org/drawingml/2006/main" name="Tema di Office">
+  <a:themeElements>
+    <a:clrScheme name="Office">
+      <a:dk1>
+        <a:sysClr val="windowText" lastClr="000000"/>
+      </a:dk1>
+      <a:lt1>
+        <a:sysClr val="window" lastClr="FFFFFF"/>
+      </a:lt1>
+      <a:dk2>
+        <a:srgbClr val="0E2841"/>
+      </a:dk2>
+      <a:lt2>
+        <a:srgbClr val="E8E8E8"/>
+      </a:lt2>
+      <a:accent1>
+        <a:srgbClr val="156082"/>
+      </a:accent1>
+      <a:accent2>
+        <a:srgbClr val="E97132"/>
+      </a:accent2>
+      <a:accent3>
+        <a:srgbClr val="196B24"/>
+      </a:accent3>
+      <a:accent4>
+        <a:srgbClr val="0F9ED5"/>
+      </a:accent4>
+      <a:accent5>
+        <a:srgbClr val="A02B93"/>
+      </a:accent5>
+      <a:accent6>
+        <a:srgbClr val="4EA72E"/>
+      </a:accent6>
+      <a:hlink>
+        <a:srgbClr val="467886"/>
+      </a:hlink>
+      <a:folHlink>
+        <a:srgbClr val="96607D"/>
+      </a:folHlink>
+    </a:clrScheme>
+    <a:fontScheme name="Office">
+      <a:majorFont>
+        <a:latin typeface="Aptos Display" panose="02110004020202020204"/>
+        <a:ea typeface=""/>
+        <a:cs typeface=""/>
+        <a:font script="Jpan" typeface="游ゴシック Light"/>
+        <a:font script="Hang" typeface="맑은 고딕"/>
+        <a:font script="Hans" typeface="等线 Light"/>
+        <a:font script="Hant" typeface="新細明體"/>
+        <a:font script="Arab" typeface="Times New Roman"/>
+        <a:font script="Hebr" typeface="Times New Roman"/>
+        <a:font script="Thai" typeface="Angsana New"/>
+        <a:font script="Ethi" typeface="Nyala"/>
+        <a:font script="Beng" typeface="Vrinda"/>
+        <a:font script="Gujr" typeface="Shruti"/>
+        <a:font script="Khmr" typeface="MoolBoran"/>
+        <a:font script="Knda" typeface="Tunga"/>
+        <a:font script="Guru" typeface="Raavi"/>
+        <a:font script="Cans" typeface="Euphemia"/>
+        <a:font script="Cher" typeface="Plantagenet Cherokee"/>
+        <a:font script="Yiii" typeface="Microsoft Yi Baiti"/>
+        <a:font script="Tibt" typeface="Microsoft Himalaya"/>
+        <a:font script="Thaa" typeface="MV Boli"/>
+        <a:font script="Deva" typeface="Mangal"/>
+        <a:font script="Telu" typeface="Gautami"/>
+        <a:font script="Taml" typeface="Latha"/>
+        <a:font script="Syrc" typeface="Estrangelo Edessa"/>
+        <a:font script="Orya" typeface="Kalinga"/>
+        <a:font script="Mlym" typeface="Kartika"/>
+        <a:font script="Laoo" typeface="DokChampa"/>
+        <a:font script="Sinh" typeface="Iskoola Pota"/>
+        <a:font script="Mong" typeface="Mongolian Baiti"/>
+        <a:font script="Viet" typeface="Times New Roman"/>
+        <a:font script="Uigh" typeface="Microsoft Uighur"/>
+        <a:font script="Geor" typeface="Sylfaen"/>
+        <a:font script="Armn" typeface="Arial"/>
+        <a:font script="Bugi" typeface="Leelawadee UI"/>
+        <a:font script="Bopo" typeface="Microsoft JhengHei"/>
+        <a:font script="Java" typeface="Javanese Text"/>
+        <a:font script="Lisu" typeface="Segoe UI"/>
+        <a:font script="Mymr" typeface="Myanmar Text"/>
+        <a:font script="Nkoo" typeface="Ebrima"/>
+        <a:font script="Olck" typeface="Nirmala UI"/>
+        <a:font script="Osma" typeface="Ebrima"/>
+        <a:font script="Phag" typeface="Phagspa"/>
+        <a:font script="Syrn" typeface="Estrangelo Edessa"/>
+        <a:font script="Syrj" typeface="Estrangelo Edessa"/>
+        <a:font script="Syre" typeface="Estrangelo Edessa"/>
+        <a:font script="Sora" typeface="Nirmala UI"/>
+        <a:font script="Tale" typeface="Microsoft Tai Le"/>
+        <a:font script="Talu" typeface="Microsoft New Tai Lue"/>
+        <a:font script="Tfng" typeface="Ebrima"/>
+      </a:majorFont>
+      <a:minorFont>
+        <a:latin typeface="Aptos" panose="02110004020202020204"/>
+        <a:ea typeface=""/>
+        <a:cs typeface=""/>
+        <a:font script="Jpan" typeface="游ゴシック"/>
+        <a:font script="Hang" typeface="맑은 고딕"/>
+        <a:font script="Hans" typeface="等线"/>
+        <a:font script="Hant" typeface="新細明體"/>
+        <a:font script="Arab" typeface="Arial"/>
+        <a:font script="Hebr" typeface="Arial"/>
+        <a:font script="Thai" typeface="Cordia New"/>
+        <a:font script="Ethi" typeface="Nyala"/>
+        <a:font script="Beng" typeface="Vrinda"/>
+        <a:font script="Gujr" typeface="Shruti"/>
+        <a:font script="Khmr" typeface="DaunPenh"/>
+        <a:font script="Knda" typeface="Tunga"/>
+        <a:font script="Guru" typeface="Raavi"/>
+        <a:font script="Cans" typeface="Euphemia"/>
+        <a:font script="Cher" typeface="Plantagenet Cherokee"/>
+        <a:font script="Yiii" typeface="Microsoft Yi Baiti"/>
+        <a:font script="Tibt" typeface="Microsoft Himalaya"/>
+        <a:font script="Thaa" typeface="MV Boli"/>
+        <a:font script="Deva" typeface="Mangal"/>
+        <a:font script="Telu" typeface="Gautami"/>
+        <a:font script="Taml" typeface="Latha"/>
+        <a:font script="Syrc" typeface="Estrangelo Edessa"/>
+        <a:font script="Orya" typeface="Kalinga"/>
+        <a:font script="Mlym" typeface="Kartika"/>
+        <a:font script="Laoo" typeface="DokChampa"/>
+        <a:font script="Sinh" typeface="Iskoola Pota"/>
+        <a:font script="Mong" typeface="Mongolian Baiti"/>
+        <a:font script="Viet" typeface="Arial"/>
+        <a:font script="Uigh" typeface="Microsoft Uighur"/>
+        <a:font script="Geor" typeface="Sylfaen"/>
+        <a:font script="Armn" typeface="Arial"/>
+        <a:font script="Bugi" typeface="Leelawadee UI"/>
+        <a:font script="Bopo" typeface="Microsoft JhengHei"/>
+        <a:font script="Java" typeface="Javanese Text"/>
+        <a:font script="Lisu" typeface="Segoe UI"/>
+        <a:font script="Mymr" typeface="Myanmar Text"/>
+        <a:font script="Nkoo" typeface="Ebrima"/>
+        <a:font script="Olck" typeface="Nirmala UI"/>
+        <a:font script="Osma" typeface="Ebrima"/>
+        <a:font script="Phag" typeface="Phagspa"/>
+        <a:font script="Syrn" typeface="Estrangelo Edessa"/>
+        <a:font script="Syrj" typeface="Estrangelo Edessa"/>
+        <a:font script="Syre" typeface="Estrangelo Edessa"/>
+        <a:font script="Sora" typeface="Nirmala UI"/>
+        <a:font script="Tale" typeface="Microsoft Tai Le"/>
+        <a:font script="Talu" typeface="Microsoft New Tai Lue"/>
+        <a:font script="Tfng" typeface="Ebrima"/>
+      </a:minorFont>
+    </a:fontScheme>
+    <a:fmtScheme name="Office">
+      <a:fillStyleLst>
+        <a:solidFill>
+          <a:schemeClr val="phClr"/>
+        </a:solidFill>
+        <a:gradFill rotWithShape="1">
+          <a:gsLst>
+            <a:gs pos="0">
+              <a:schemeClr val="phClr">
+                <a:lumMod val="110000"/>
+                <a:satMod val="105000"/>
+                <a:tint val="67000"/>
+              </a:schemeClr>
+            </a:gs>
+            <a:gs pos="50000">
+              <a:schemeClr val="phClr">
+                <a:lumMod val="105000"/>
+                <a:satMod val="103000"/>
+                <a:tint val="73000"/>
+              </a:schemeClr>
+            </a:gs>
+            <a:gs pos="100000">
+              <a:schemeClr val="phClr">
+                <a:lumMod val="105000"/>
+                <a:satMod val="109000"/>
+                <a:tint val="81000"/>
+              </a:schemeClr>
+            </a:gs>
+          </a:gsLst>
+          <a:lin ang="5400000" scaled="0"/>
+        </a:gradFill>
+        <a:gradFill rotWithShape="1">
+          <a:gsLst>
+            <a:gs pos="0">
+              <a:schemeClr val="phClr">
+                <a:satMod val="103000"/>
+                <a:lumMod val="102000"/>
+                <a:tint val="94000"/>
+              </a:schemeClr>
+            </a:gs>
+            <a:gs pos="50000">
+              <a:schemeClr val="phClr">
+                <a:satMod val="110000"/>
+                <a:lumMod val="100000"/>
+                <a:shade val="100000"/>
+              </a:schemeClr>
+            </a:gs>
+            <a:gs pos="100000">
+              <a:schemeClr val="phClr">
+                <a:lumMod val="99000"/>
+                <a:satMod val="120000"/>
+                <a:shade val="78000"/>
+              </a:schemeClr>
+            </a:gs>
+          </a:gsLst>
+          <a:lin ang="5400000" scaled="0"/>
+        </a:gradFill>
+      </a:fillStyleLst>
+      <a:lnStyleLst>
+        <a:ln w="12700" cap="flat" cmpd="sng" algn="ctr">
+          <a:solidFill>
+            <a:schemeClr val="phClr"/>
+          </a:solidFill>
+          <a:prstDash val="solid"/>
+          <a:miter lim="800000"/>
+        </a:ln>
+        <a:ln w="19050" cap="flat" cmpd="sng" algn="ctr">
+          <a:solidFill>
+            <a:schemeClr val="phClr"/>
+          </a:solidFill>
+          <a:prstDash val="solid"/>
+          <a:miter lim="800000"/>
+        </a:ln>
+        <a:ln w="25400" cap="flat" cmpd="sng" algn="ctr">
+          <a:solidFill>
+            <a:schemeClr val="phClr"/>
+          </a:solidFill>
+          <a:prstDash val="solid"/>
+          <a:miter lim="800000"/>
+        </a:ln>
+      </a:lnStyleLst>
+      <a:effectStyleLst>
+        <a:effectStyle>
+          <a:effectLst/>
+        </a:effectStyle>
+        <a:effectStyle>
+          <a:effectLst/>
+        </a:effectStyle>
+        <a:effectStyle>
+          <a:effectLst>
+            <a:outerShdw blurRad="57150" dist="19050" dir="5400000" algn="ctr" rotWithShape="0">
+              <a:srgbClr val="000000">
+                <a:alpha val="63000"/>
+              </a:srgbClr>
+            </a:outerShdw>
+          </a:effectLst>
+        </a:effectStyle>
+      </a:effectStyleLst>
+      <a:bgFillStyleLst>
+        <a:solidFill>
+          <a:schemeClr val="phClr"/>
+        </a:solidFill>
+        <a:solidFill>
+          <a:schemeClr val="phClr">
+            <a:tint val="95000"/>
+            <a:satMod val="170000"/>
+          </a:schemeClr>
+        </a:solidFill>
+        <a:gradFill rotWithShape="1">
+          <a:gsLst>
+            <a:gs pos="0">
+              <a:schemeClr val="phClr">
+                <a:tint val="93000"/>
+                <a:satMod val="150000"/>
+                <a:shade val="98000"/>
+                <a:lumMod val="102000"/>
+              </a:schemeClr>
+            </a:gs>
+            <a:gs pos="50000">
+              <a:schemeClr val="phClr">
+                <a:tint val="98000"/>
+                <a:satMod val="130000"/>
+                <a:shade val="90000"/>
+                <a:lumMod val="103000"/>
+              </a:schemeClr>
+            </a:gs>
+            <a:gs pos="100000">
+              <a:schemeClr val="phClr">
+                <a:shade val="63000"/>
+                <a:satMod val="120000"/>
+              </a:schemeClr>
+            </a:gs>
+          </a:gsLst>
+          <a:lin ang="5400000" scaled="0"/>
+        </a:gradFill>
+      </a:bgFillStyleLst>
+    </a:fmtScheme>
+  </a:themeElements>
+  <a:objectDefaults>
+    <a:lnDef>
+      <a:spPr/>
+      <a:bodyPr/>
+      <a:lstStyle/>
+      <a:style>
+        <a:lnRef idx="2">
+          <a:schemeClr val="accent1"/>
+        </a:lnRef>
+        <a:fillRef idx="0">
+          <a:schemeClr val="accent1"/>
+        </a:fillRef>
+        <a:effectRef idx="1">
+          <a:schemeClr val="accent1"/>
+        </a:effectRef>
+        <a:fontRef idx="minor">
+          <a:schemeClr val="tx1"/>
+        </a:fontRef>
+      </a:style>
+    </a:lnDef>
+  </a:objectDefaults>
+  <a:extraClrSchemeLst/>
+  <a:extLst>
+    <a:ext uri="{05A4C25C-085E-4340-85A3-A5531E510DB2}">
+      <thm15:themeFamily xmlns:thm15="http://schemas.microsoft.com/office/thememl/2012/main" name="Office Theme" id="{2E142A2C-CD16-42D6-873A-C26D2A0506FA}" vid="{1BDDFF52-6CD6-40A5-AB3C-68EB2F1E4D0A}"/>
+    </a:ext>
+  </a:extLst>
+</a:theme>
 </file>
</xml_diff>